<commit_message>
Fix changes on 2025-06-30
</commit_message>
<xml_diff>
--- a/ML Adv/27 - Deep Policy Gradient/Presentation/Policy Gradient.pptx
+++ b/ML Adv/27 - Deep Policy Gradient/Presentation/Policy Gradient.pptx
@@ -6,7 +6,7 @@
     <p:sldMasterId id="2147483692" r:id="rId2"/>
   </p:sldMasterIdLst>
   <p:notesMasterIdLst>
-    <p:notesMasterId r:id="rId40"/>
+    <p:notesMasterId r:id="rId38"/>
   </p:notesMasterIdLst>
   <p:sldIdLst>
     <p:sldId id="256" r:id="rId3"/>
@@ -21,58 +21,56 @@
     <p:sldId id="267" r:id="rId12"/>
     <p:sldId id="344" r:id="rId13"/>
     <p:sldId id="375" r:id="rId14"/>
-    <p:sldId id="372" r:id="rId15"/>
-    <p:sldId id="378" r:id="rId16"/>
-    <p:sldId id="393" r:id="rId17"/>
-    <p:sldId id="394" r:id="rId18"/>
-    <p:sldId id="395" r:id="rId19"/>
-    <p:sldId id="403" r:id="rId20"/>
-    <p:sldId id="339" r:id="rId21"/>
-    <p:sldId id="389" r:id="rId22"/>
-    <p:sldId id="390" r:id="rId23"/>
-    <p:sldId id="351" r:id="rId24"/>
-    <p:sldId id="352" r:id="rId25"/>
-    <p:sldId id="353" r:id="rId26"/>
-    <p:sldId id="354" r:id="rId27"/>
-    <p:sldId id="392" r:id="rId28"/>
-    <p:sldId id="377" r:id="rId29"/>
-    <p:sldId id="350" r:id="rId30"/>
-    <p:sldId id="379" r:id="rId31"/>
-    <p:sldId id="490" r:id="rId32"/>
-    <p:sldId id="278" r:id="rId33"/>
-    <p:sldId id="279" r:id="rId34"/>
-    <p:sldId id="281" r:id="rId35"/>
-    <p:sldId id="282" r:id="rId36"/>
-    <p:sldId id="345" r:id="rId37"/>
-    <p:sldId id="289" r:id="rId38"/>
-    <p:sldId id="337" r:id="rId39"/>
+    <p:sldId id="378" r:id="rId15"/>
+    <p:sldId id="393" r:id="rId16"/>
+    <p:sldId id="394" r:id="rId17"/>
+    <p:sldId id="395" r:id="rId18"/>
+    <p:sldId id="403" r:id="rId19"/>
+    <p:sldId id="339" r:id="rId20"/>
+    <p:sldId id="389" r:id="rId21"/>
+    <p:sldId id="390" r:id="rId22"/>
+    <p:sldId id="351" r:id="rId23"/>
+    <p:sldId id="352" r:id="rId24"/>
+    <p:sldId id="353" r:id="rId25"/>
+    <p:sldId id="354" r:id="rId26"/>
+    <p:sldId id="377" r:id="rId27"/>
+    <p:sldId id="350" r:id="rId28"/>
+    <p:sldId id="379" r:id="rId29"/>
+    <p:sldId id="490" r:id="rId30"/>
+    <p:sldId id="278" r:id="rId31"/>
+    <p:sldId id="279" r:id="rId32"/>
+    <p:sldId id="281" r:id="rId33"/>
+    <p:sldId id="282" r:id="rId34"/>
+    <p:sldId id="345" r:id="rId35"/>
+    <p:sldId id="289" r:id="rId36"/>
+    <p:sldId id="337" r:id="rId37"/>
   </p:sldIdLst>
   <p:sldSz cx="9144000" cy="5143500" type="screen16x9"/>
   <p:notesSz cx="6858000" cy="9144000"/>
   <p:embeddedFontLst>
     <p:embeddedFont>
       <p:font typeface="Cambria Math" panose="02040503050406030204" pitchFamily="18" charset="0"/>
-      <p:regular r:id="rId41"/>
+      <p:regular r:id="rId39"/>
     </p:embeddedFont>
     <p:embeddedFont>
       <p:font typeface="Helvetica Neue" panose="02000503000000020004" pitchFamily="2" charset="0"/>
-      <p:regular r:id="rId42"/>
-      <p:bold r:id="rId43"/>
-      <p:italic r:id="rId44"/>
-      <p:boldItalic r:id="rId45"/>
+      <p:regular r:id="rId40"/>
+      <p:bold r:id="rId41"/>
+      <p:italic r:id="rId42"/>
+      <p:boldItalic r:id="rId43"/>
     </p:embeddedFont>
     <p:embeddedFont>
       <p:font typeface="PTSerif" panose="020A0603040505020204" pitchFamily="18" charset="77"/>
-      <p:bold r:id="rId46"/>
-      <p:italic r:id="rId47"/>
-      <p:boldItalic r:id="rId48"/>
+      <p:bold r:id="rId44"/>
+      <p:italic r:id="rId45"/>
+      <p:boldItalic r:id="rId46"/>
     </p:embeddedFont>
     <p:embeddedFont>
       <p:font typeface="Roboto" panose="02000000000000000000" pitchFamily="2" charset="0"/>
-      <p:regular r:id="rId49"/>
-      <p:bold r:id="rId50"/>
-      <p:italic r:id="rId51"/>
-      <p:boldItalic r:id="rId52"/>
+      <p:regular r:id="rId47"/>
+      <p:bold r:id="rId48"/>
+      <p:italic r:id="rId49"/>
+      <p:boldItalic r:id="rId50"/>
     </p:embeddedFont>
   </p:embeddedFontLst>
   <p:defaultTextStyle>
@@ -1185,7 +1183,7 @@
     </p:spTree>
     <p:extLst>
       <p:ext uri="{BB962C8B-B14F-4D97-AF65-F5344CB8AC3E}">
-        <p14:creationId xmlns:p14="http://schemas.microsoft.com/office/powerpoint/2010/main" val="3139398538"/>
+        <p14:creationId xmlns:p14="http://schemas.microsoft.com/office/powerpoint/2010/main" val="4002501593"/>
       </p:ext>
     </p:extLst>
   </p:cSld>
@@ -1196,6 +1194,115 @@
 </file>
 
 <file path=ppt/notesSlides/notesSlide13.xml><?xml version="1.0" encoding="utf-8"?>
+<p:notes xmlns:a="http://schemas.openxmlformats.org/drawingml/2006/main" xmlns:r="http://schemas.openxmlformats.org/officeDocument/2006/relationships" xmlns:p="http://schemas.openxmlformats.org/presentationml/2006/main" showMasterSp="0" showMasterPhAnim="0">
+  <p:cSld>
+    <p:spTree>
+      <p:nvGrpSpPr>
+        <p:cNvPr id="1" name="Shape 301"/>
+        <p:cNvGrpSpPr/>
+        <p:nvPr/>
+      </p:nvGrpSpPr>
+      <p:grpSpPr>
+        <a:xfrm>
+          <a:off x="0" y="0"/>
+          <a:ext cx="0" cy="0"/>
+          <a:chOff x="0" y="0"/>
+          <a:chExt cx="0" cy="0"/>
+        </a:xfrm>
+      </p:grpSpPr>
+      <p:sp>
+        <p:nvSpPr>
+          <p:cNvPr id="302" name="Google Shape;302;gdf29b9fb24_0_22:notes"/>
+          <p:cNvSpPr>
+            <a:spLocks noGrp="1" noRot="1" noChangeAspect="1"/>
+          </p:cNvSpPr>
+          <p:nvPr>
+            <p:ph type="sldImg" idx="2"/>
+          </p:nvPr>
+        </p:nvSpPr>
+        <p:spPr>
+          <a:xfrm>
+            <a:off x="381000" y="685800"/>
+            <a:ext cx="6096000" cy="3429000"/>
+          </a:xfrm>
+          <a:custGeom>
+            <a:avLst/>
+            <a:gdLst/>
+            <a:ahLst/>
+            <a:cxnLst/>
+            <a:rect l="l" t="t" r="r" b="b"/>
+            <a:pathLst>
+              <a:path w="120000" h="120000" extrusionOk="0">
+                <a:moveTo>
+                  <a:pt x="0" y="0"/>
+                </a:moveTo>
+                <a:lnTo>
+                  <a:pt x="120000" y="0"/>
+                </a:lnTo>
+                <a:lnTo>
+                  <a:pt x="120000" y="120000"/>
+                </a:lnTo>
+                <a:lnTo>
+                  <a:pt x="0" y="120000"/>
+                </a:lnTo>
+                <a:close/>
+              </a:path>
+            </a:pathLst>
+          </a:custGeom>
+        </p:spPr>
+      </p:sp>
+      <p:sp>
+        <p:nvSpPr>
+          <p:cNvPr id="303" name="Google Shape;303;gdf29b9fb24_0_22:notes"/>
+          <p:cNvSpPr txBox="1">
+            <a:spLocks noGrp="1"/>
+          </p:cNvSpPr>
+          <p:nvPr>
+            <p:ph type="body" idx="1"/>
+          </p:nvPr>
+        </p:nvSpPr>
+        <p:spPr>
+          <a:xfrm>
+            <a:off x="685800" y="4343400"/>
+            <a:ext cx="5486400" cy="4114800"/>
+          </a:xfrm>
+          <a:prstGeom prst="rect">
+            <a:avLst/>
+          </a:prstGeom>
+        </p:spPr>
+        <p:txBody>
+          <a:bodyPr spcFirstLastPara="1" wrap="square" lIns="91425" tIns="91425" rIns="91425" bIns="91425" anchor="t" anchorCtr="0">
+            <a:noAutofit/>
+          </a:bodyPr>
+          <a:lstStyle/>
+          <a:p>
+            <a:pPr marL="0" lvl="0" indent="0" algn="l" rtl="0">
+              <a:spcBef>
+                <a:spcPts val="0"/>
+              </a:spcBef>
+              <a:spcAft>
+                <a:spcPts val="0"/>
+              </a:spcAft>
+              <a:buNone/>
+            </a:pPr>
+            <a:endParaRPr/>
+          </a:p>
+        </p:txBody>
+      </p:sp>
+    </p:spTree>
+    <p:extLst>
+      <p:ext uri="{BB962C8B-B14F-4D97-AF65-F5344CB8AC3E}">
+        <p14:creationId xmlns:p14="http://schemas.microsoft.com/office/powerpoint/2010/main" val="236742400"/>
+      </p:ext>
+    </p:extLst>
+  </p:cSld>
+  <p:clrMapOvr>
+    <a:masterClrMapping/>
+  </p:clrMapOvr>
+</p:notes>
+</file>
+
+<file path=ppt/notesSlides/notesSlide14.xml><?xml version="1.0" encoding="utf-8"?>
 <p:notes xmlns:a="http://schemas.openxmlformats.org/drawingml/2006/main" xmlns:r="http://schemas.openxmlformats.org/officeDocument/2006/relationships" xmlns:p="http://schemas.openxmlformats.org/presentationml/2006/main" showMasterSp="0" showMasterPhAnim="0">
   <p:cSld>
     <p:spTree>
@@ -1294,116 +1401,7 @@
     </p:spTree>
     <p:extLst>
       <p:ext uri="{BB962C8B-B14F-4D97-AF65-F5344CB8AC3E}">
-        <p14:creationId xmlns:p14="http://schemas.microsoft.com/office/powerpoint/2010/main" val="4002501593"/>
-      </p:ext>
-    </p:extLst>
-  </p:cSld>
-  <p:clrMapOvr>
-    <a:masterClrMapping/>
-  </p:clrMapOvr>
-</p:notes>
-</file>
-
-<file path=ppt/notesSlides/notesSlide14.xml><?xml version="1.0" encoding="utf-8"?>
-<p:notes xmlns:a="http://schemas.openxmlformats.org/drawingml/2006/main" xmlns:r="http://schemas.openxmlformats.org/officeDocument/2006/relationships" xmlns:p="http://schemas.openxmlformats.org/presentationml/2006/main" showMasterSp="0" showMasterPhAnim="0">
-  <p:cSld>
-    <p:spTree>
-      <p:nvGrpSpPr>
-        <p:cNvPr id="1" name="Shape 301"/>
-        <p:cNvGrpSpPr/>
-        <p:nvPr/>
-      </p:nvGrpSpPr>
-      <p:grpSpPr>
-        <a:xfrm>
-          <a:off x="0" y="0"/>
-          <a:ext cx="0" cy="0"/>
-          <a:chOff x="0" y="0"/>
-          <a:chExt cx="0" cy="0"/>
-        </a:xfrm>
-      </p:grpSpPr>
-      <p:sp>
-        <p:nvSpPr>
-          <p:cNvPr id="302" name="Google Shape;302;gdf29b9fb24_0_22:notes"/>
-          <p:cNvSpPr>
-            <a:spLocks noGrp="1" noRot="1" noChangeAspect="1"/>
-          </p:cNvSpPr>
-          <p:nvPr>
-            <p:ph type="sldImg" idx="2"/>
-          </p:nvPr>
-        </p:nvSpPr>
-        <p:spPr>
-          <a:xfrm>
-            <a:off x="381000" y="685800"/>
-            <a:ext cx="6096000" cy="3429000"/>
-          </a:xfrm>
-          <a:custGeom>
-            <a:avLst/>
-            <a:gdLst/>
-            <a:ahLst/>
-            <a:cxnLst/>
-            <a:rect l="l" t="t" r="r" b="b"/>
-            <a:pathLst>
-              <a:path w="120000" h="120000" extrusionOk="0">
-                <a:moveTo>
-                  <a:pt x="0" y="0"/>
-                </a:moveTo>
-                <a:lnTo>
-                  <a:pt x="120000" y="0"/>
-                </a:lnTo>
-                <a:lnTo>
-                  <a:pt x="120000" y="120000"/>
-                </a:lnTo>
-                <a:lnTo>
-                  <a:pt x="0" y="120000"/>
-                </a:lnTo>
-                <a:close/>
-              </a:path>
-            </a:pathLst>
-          </a:custGeom>
-        </p:spPr>
-      </p:sp>
-      <p:sp>
-        <p:nvSpPr>
-          <p:cNvPr id="303" name="Google Shape;303;gdf29b9fb24_0_22:notes"/>
-          <p:cNvSpPr txBox="1">
-            <a:spLocks noGrp="1"/>
-          </p:cNvSpPr>
-          <p:nvPr>
-            <p:ph type="body" idx="1"/>
-          </p:nvPr>
-        </p:nvSpPr>
-        <p:spPr>
-          <a:xfrm>
-            <a:off x="685800" y="4343400"/>
-            <a:ext cx="5486400" cy="4114800"/>
-          </a:xfrm>
-          <a:prstGeom prst="rect">
-            <a:avLst/>
-          </a:prstGeom>
-        </p:spPr>
-        <p:txBody>
-          <a:bodyPr spcFirstLastPara="1" wrap="square" lIns="91425" tIns="91425" rIns="91425" bIns="91425" anchor="t" anchorCtr="0">
-            <a:noAutofit/>
-          </a:bodyPr>
-          <a:lstStyle/>
-          <a:p>
-            <a:pPr marL="0" lvl="0" indent="0" algn="l" rtl="0">
-              <a:spcBef>
-                <a:spcPts val="0"/>
-              </a:spcBef>
-              <a:spcAft>
-                <a:spcPts val="0"/>
-              </a:spcAft>
-              <a:buNone/>
-            </a:pPr>
-            <a:endParaRPr/>
-          </a:p>
-        </p:txBody>
-      </p:sp>
-    </p:spTree>
-    <p:extLst>
-      <p:ext uri="{BB962C8B-B14F-4D97-AF65-F5344CB8AC3E}">
-        <p14:creationId xmlns:p14="http://schemas.microsoft.com/office/powerpoint/2010/main" val="236742400"/>
+        <p14:creationId xmlns:p14="http://schemas.microsoft.com/office/powerpoint/2010/main" val="443033198"/>
       </p:ext>
     </p:extLst>
   </p:cSld>
@@ -1512,7 +1510,7 @@
     </p:spTree>
     <p:extLst>
       <p:ext uri="{BB962C8B-B14F-4D97-AF65-F5344CB8AC3E}">
-        <p14:creationId xmlns:p14="http://schemas.microsoft.com/office/powerpoint/2010/main" val="443033198"/>
+        <p14:creationId xmlns:p14="http://schemas.microsoft.com/office/powerpoint/2010/main" val="2969545654"/>
       </p:ext>
     </p:extLst>
   </p:cSld>
@@ -1621,7 +1619,7 @@
     </p:spTree>
     <p:extLst>
       <p:ext uri="{BB962C8B-B14F-4D97-AF65-F5344CB8AC3E}">
-        <p14:creationId xmlns:p14="http://schemas.microsoft.com/office/powerpoint/2010/main" val="2969545654"/>
+        <p14:creationId xmlns:p14="http://schemas.microsoft.com/office/powerpoint/2010/main" val="2564463445"/>
       </p:ext>
     </p:extLst>
   </p:cSld>
@@ -1730,7 +1728,7 @@
     </p:spTree>
     <p:extLst>
       <p:ext uri="{BB962C8B-B14F-4D97-AF65-F5344CB8AC3E}">
-        <p14:creationId xmlns:p14="http://schemas.microsoft.com/office/powerpoint/2010/main" val="2564463445"/>
+        <p14:creationId xmlns:p14="http://schemas.microsoft.com/office/powerpoint/2010/main" val="2013310985"/>
       </p:ext>
     </p:extLst>
   </p:cSld>
@@ -1839,7 +1837,7 @@
     </p:spTree>
     <p:extLst>
       <p:ext uri="{BB962C8B-B14F-4D97-AF65-F5344CB8AC3E}">
-        <p14:creationId xmlns:p14="http://schemas.microsoft.com/office/powerpoint/2010/main" val="2013310985"/>
+        <p14:creationId xmlns:p14="http://schemas.microsoft.com/office/powerpoint/2010/main" val="694201515"/>
       </p:ext>
     </p:extLst>
   </p:cSld>
@@ -1948,7 +1946,7 @@
     </p:spTree>
     <p:extLst>
       <p:ext uri="{BB962C8B-B14F-4D97-AF65-F5344CB8AC3E}">
-        <p14:creationId xmlns:p14="http://schemas.microsoft.com/office/powerpoint/2010/main" val="694201515"/>
+        <p14:creationId xmlns:p14="http://schemas.microsoft.com/office/powerpoint/2010/main" val="12317059"/>
       </p:ext>
     </p:extLst>
   </p:cSld>
@@ -2161,7 +2159,7 @@
     </p:spTree>
     <p:extLst>
       <p:ext uri="{BB962C8B-B14F-4D97-AF65-F5344CB8AC3E}">
-        <p14:creationId xmlns:p14="http://schemas.microsoft.com/office/powerpoint/2010/main" val="30963055"/>
+        <p14:creationId xmlns:p14="http://schemas.microsoft.com/office/powerpoint/2010/main" val="3174161821"/>
       </p:ext>
     </p:extLst>
   </p:cSld>
@@ -2270,7 +2268,7 @@
     </p:spTree>
     <p:extLst>
       <p:ext uri="{BB962C8B-B14F-4D97-AF65-F5344CB8AC3E}">
-        <p14:creationId xmlns:p14="http://schemas.microsoft.com/office/powerpoint/2010/main" val="12317059"/>
+        <p14:creationId xmlns:p14="http://schemas.microsoft.com/office/powerpoint/2010/main" val="1750156900"/>
       </p:ext>
     </p:extLst>
   </p:cSld>
@@ -2281,224 +2279,6 @@
 </file>
 
 <file path=ppt/notesSlides/notesSlide22.xml><?xml version="1.0" encoding="utf-8"?>
-<p:notes xmlns:a="http://schemas.openxmlformats.org/drawingml/2006/main" xmlns:r="http://schemas.openxmlformats.org/officeDocument/2006/relationships" xmlns:p="http://schemas.openxmlformats.org/presentationml/2006/main" showMasterSp="0" showMasterPhAnim="0">
-  <p:cSld>
-    <p:spTree>
-      <p:nvGrpSpPr>
-        <p:cNvPr id="1" name="Shape 306"/>
-        <p:cNvGrpSpPr/>
-        <p:nvPr/>
-      </p:nvGrpSpPr>
-      <p:grpSpPr>
-        <a:xfrm>
-          <a:off x="0" y="0"/>
-          <a:ext cx="0" cy="0"/>
-          <a:chOff x="0" y="0"/>
-          <a:chExt cx="0" cy="0"/>
-        </a:xfrm>
-      </p:grpSpPr>
-      <p:sp>
-        <p:nvSpPr>
-          <p:cNvPr id="307" name="Google Shape;307;gdf29b9fb24_0_69:notes"/>
-          <p:cNvSpPr>
-            <a:spLocks noGrp="1" noRot="1" noChangeAspect="1"/>
-          </p:cNvSpPr>
-          <p:nvPr>
-            <p:ph type="sldImg" idx="2"/>
-          </p:nvPr>
-        </p:nvSpPr>
-        <p:spPr>
-          <a:xfrm>
-            <a:off x="381000" y="685800"/>
-            <a:ext cx="6096000" cy="3429000"/>
-          </a:xfrm>
-          <a:custGeom>
-            <a:avLst/>
-            <a:gdLst/>
-            <a:ahLst/>
-            <a:cxnLst/>
-            <a:rect l="l" t="t" r="r" b="b"/>
-            <a:pathLst>
-              <a:path w="120000" h="120000" extrusionOk="0">
-                <a:moveTo>
-                  <a:pt x="0" y="0"/>
-                </a:moveTo>
-                <a:lnTo>
-                  <a:pt x="120000" y="0"/>
-                </a:lnTo>
-                <a:lnTo>
-                  <a:pt x="120000" y="120000"/>
-                </a:lnTo>
-                <a:lnTo>
-                  <a:pt x="0" y="120000"/>
-                </a:lnTo>
-                <a:close/>
-              </a:path>
-            </a:pathLst>
-          </a:custGeom>
-        </p:spPr>
-      </p:sp>
-      <p:sp>
-        <p:nvSpPr>
-          <p:cNvPr id="308" name="Google Shape;308;gdf29b9fb24_0_69:notes"/>
-          <p:cNvSpPr txBox="1">
-            <a:spLocks noGrp="1"/>
-          </p:cNvSpPr>
-          <p:nvPr>
-            <p:ph type="body" idx="1"/>
-          </p:nvPr>
-        </p:nvSpPr>
-        <p:spPr>
-          <a:xfrm>
-            <a:off x="685800" y="4343400"/>
-            <a:ext cx="5486400" cy="4114800"/>
-          </a:xfrm>
-          <a:prstGeom prst="rect">
-            <a:avLst/>
-          </a:prstGeom>
-        </p:spPr>
-        <p:txBody>
-          <a:bodyPr spcFirstLastPara="1" wrap="square" lIns="91425" tIns="91425" rIns="91425" bIns="91425" anchor="t" anchorCtr="0">
-            <a:noAutofit/>
-          </a:bodyPr>
-          <a:lstStyle/>
-          <a:p>
-            <a:pPr marL="0" lvl="0" indent="0" algn="l" rtl="0">
-              <a:spcBef>
-                <a:spcPts val="0"/>
-              </a:spcBef>
-              <a:spcAft>
-                <a:spcPts val="0"/>
-              </a:spcAft>
-              <a:buNone/>
-            </a:pPr>
-            <a:endParaRPr/>
-          </a:p>
-        </p:txBody>
-      </p:sp>
-    </p:spTree>
-    <p:extLst>
-      <p:ext uri="{BB962C8B-B14F-4D97-AF65-F5344CB8AC3E}">
-        <p14:creationId xmlns:p14="http://schemas.microsoft.com/office/powerpoint/2010/main" val="3174161821"/>
-      </p:ext>
-    </p:extLst>
-  </p:cSld>
-  <p:clrMapOvr>
-    <a:masterClrMapping/>
-  </p:clrMapOvr>
-</p:notes>
-</file>
-
-<file path=ppt/notesSlides/notesSlide23.xml><?xml version="1.0" encoding="utf-8"?>
-<p:notes xmlns:a="http://schemas.openxmlformats.org/drawingml/2006/main" xmlns:r="http://schemas.openxmlformats.org/officeDocument/2006/relationships" xmlns:p="http://schemas.openxmlformats.org/presentationml/2006/main" showMasterSp="0" showMasterPhAnim="0">
-  <p:cSld>
-    <p:spTree>
-      <p:nvGrpSpPr>
-        <p:cNvPr id="1" name="Shape 306"/>
-        <p:cNvGrpSpPr/>
-        <p:nvPr/>
-      </p:nvGrpSpPr>
-      <p:grpSpPr>
-        <a:xfrm>
-          <a:off x="0" y="0"/>
-          <a:ext cx="0" cy="0"/>
-          <a:chOff x="0" y="0"/>
-          <a:chExt cx="0" cy="0"/>
-        </a:xfrm>
-      </p:grpSpPr>
-      <p:sp>
-        <p:nvSpPr>
-          <p:cNvPr id="307" name="Google Shape;307;gdf29b9fb24_0_69:notes"/>
-          <p:cNvSpPr>
-            <a:spLocks noGrp="1" noRot="1" noChangeAspect="1"/>
-          </p:cNvSpPr>
-          <p:nvPr>
-            <p:ph type="sldImg" idx="2"/>
-          </p:nvPr>
-        </p:nvSpPr>
-        <p:spPr>
-          <a:xfrm>
-            <a:off x="381000" y="685800"/>
-            <a:ext cx="6096000" cy="3429000"/>
-          </a:xfrm>
-          <a:custGeom>
-            <a:avLst/>
-            <a:gdLst/>
-            <a:ahLst/>
-            <a:cxnLst/>
-            <a:rect l="l" t="t" r="r" b="b"/>
-            <a:pathLst>
-              <a:path w="120000" h="120000" extrusionOk="0">
-                <a:moveTo>
-                  <a:pt x="0" y="0"/>
-                </a:moveTo>
-                <a:lnTo>
-                  <a:pt x="120000" y="0"/>
-                </a:lnTo>
-                <a:lnTo>
-                  <a:pt x="120000" y="120000"/>
-                </a:lnTo>
-                <a:lnTo>
-                  <a:pt x="0" y="120000"/>
-                </a:lnTo>
-                <a:close/>
-              </a:path>
-            </a:pathLst>
-          </a:custGeom>
-        </p:spPr>
-      </p:sp>
-      <p:sp>
-        <p:nvSpPr>
-          <p:cNvPr id="308" name="Google Shape;308;gdf29b9fb24_0_69:notes"/>
-          <p:cNvSpPr txBox="1">
-            <a:spLocks noGrp="1"/>
-          </p:cNvSpPr>
-          <p:nvPr>
-            <p:ph type="body" idx="1"/>
-          </p:nvPr>
-        </p:nvSpPr>
-        <p:spPr>
-          <a:xfrm>
-            <a:off x="685800" y="4343400"/>
-            <a:ext cx="5486400" cy="4114800"/>
-          </a:xfrm>
-          <a:prstGeom prst="rect">
-            <a:avLst/>
-          </a:prstGeom>
-        </p:spPr>
-        <p:txBody>
-          <a:bodyPr spcFirstLastPara="1" wrap="square" lIns="91425" tIns="91425" rIns="91425" bIns="91425" anchor="t" anchorCtr="0">
-            <a:noAutofit/>
-          </a:bodyPr>
-          <a:lstStyle/>
-          <a:p>
-            <a:pPr marL="0" lvl="0" indent="0" algn="l" rtl="0">
-              <a:spcBef>
-                <a:spcPts val="0"/>
-              </a:spcBef>
-              <a:spcAft>
-                <a:spcPts val="0"/>
-              </a:spcAft>
-              <a:buNone/>
-            </a:pPr>
-            <a:endParaRPr/>
-          </a:p>
-        </p:txBody>
-      </p:sp>
-    </p:spTree>
-    <p:extLst>
-      <p:ext uri="{BB962C8B-B14F-4D97-AF65-F5344CB8AC3E}">
-        <p14:creationId xmlns:p14="http://schemas.microsoft.com/office/powerpoint/2010/main" val="1750156900"/>
-      </p:ext>
-    </p:extLst>
-  </p:cSld>
-  <p:clrMapOvr>
-    <a:masterClrMapping/>
-  </p:clrMapOvr>
-</p:notes>
-</file>
-
-<file path=ppt/notesSlides/notesSlide24.xml><?xml version="1.0" encoding="utf-8"?>
 <p:notes xmlns:a="http://schemas.openxmlformats.org/drawingml/2006/main" xmlns:r="http://schemas.openxmlformats.org/officeDocument/2006/relationships" xmlns:p="http://schemas.openxmlformats.org/presentationml/2006/main" showMasterSp="0" showMasterPhAnim="0">
   <p:cSld>
     <p:spTree>
@@ -2602,7 +2382,7 @@
 </p:notes>
 </file>
 
-<file path=ppt/notesSlides/notesSlide25.xml><?xml version="1.0" encoding="utf-8"?>
+<file path=ppt/notesSlides/notesSlide23.xml><?xml version="1.0" encoding="utf-8"?>
 <p:notes xmlns:a="http://schemas.openxmlformats.org/drawingml/2006/main" xmlns:r="http://schemas.openxmlformats.org/officeDocument/2006/relationships" xmlns:p="http://schemas.openxmlformats.org/presentationml/2006/main" showMasterSp="0" showMasterPhAnim="0">
   <p:cSld>
     <p:spTree>
@@ -2706,7 +2486,7 @@
 </p:notes>
 </file>
 
-<file path=ppt/notesSlides/notesSlide26.xml><?xml version="1.0" encoding="utf-8"?>
+<file path=ppt/notesSlides/notesSlide24.xml><?xml version="1.0" encoding="utf-8"?>
 <p:notes xmlns:a="http://schemas.openxmlformats.org/drawingml/2006/main" xmlns:r="http://schemas.openxmlformats.org/officeDocument/2006/relationships" xmlns:p="http://schemas.openxmlformats.org/presentationml/2006/main" showMasterSp="0" showMasterPhAnim="0">
   <p:cSld>
     <p:spTree>
@@ -2810,7 +2590,7 @@
 </p:notes>
 </file>
 
-<file path=ppt/notesSlides/notesSlide27.xml><?xml version="1.0" encoding="utf-8"?>
+<file path=ppt/notesSlides/notesSlide25.xml><?xml version="1.0" encoding="utf-8"?>
 <p:notes xmlns:a="http://schemas.openxmlformats.org/drawingml/2006/main" xmlns:r="http://schemas.openxmlformats.org/officeDocument/2006/relationships" xmlns:p="http://schemas.openxmlformats.org/presentationml/2006/main" showMasterSp="0" showMasterPhAnim="0">
   <p:cSld>
     <p:spTree>
@@ -2914,7 +2694,7 @@
 </p:notes>
 </file>
 
-<file path=ppt/notesSlides/notesSlide28.xml><?xml version="1.0" encoding="utf-8"?>
+<file path=ppt/notesSlides/notesSlide26.xml><?xml version="1.0" encoding="utf-8"?>
 <p:notes xmlns:a="http://schemas.openxmlformats.org/drawingml/2006/main" xmlns:r="http://schemas.openxmlformats.org/officeDocument/2006/relationships" xmlns:p="http://schemas.openxmlformats.org/presentationml/2006/main" showMasterSp="0" showMasterPhAnim="0">
   <p:cSld>
     <p:spTree>
@@ -3023,7 +2803,7 @@
 </p:notes>
 </file>
 
-<file path=ppt/notesSlides/notesSlide29.xml><?xml version="1.0" encoding="utf-8"?>
+<file path=ppt/notesSlides/notesSlide27.xml><?xml version="1.0" encoding="utf-8"?>
 <p:notes xmlns:a="http://schemas.openxmlformats.org/drawingml/2006/main" xmlns:r="http://schemas.openxmlformats.org/officeDocument/2006/relationships" xmlns:p="http://schemas.openxmlformats.org/presentationml/2006/main" showMasterSp="0" showMasterPhAnim="0">
   <p:cSld>
     <p:spTree>
@@ -3127,6 +2907,110 @@
 </p:notes>
 </file>
 
+<file path=ppt/notesSlides/notesSlide28.xml><?xml version="1.0" encoding="utf-8"?>
+<p:notes xmlns:a="http://schemas.openxmlformats.org/drawingml/2006/main" xmlns:r="http://schemas.openxmlformats.org/officeDocument/2006/relationships" xmlns:p="http://schemas.openxmlformats.org/presentationml/2006/main" showMasterSp="0" showMasterPhAnim="0">
+  <p:cSld>
+    <p:spTree>
+      <p:nvGrpSpPr>
+        <p:cNvPr id="1" name="Shape 476"/>
+        <p:cNvGrpSpPr/>
+        <p:nvPr/>
+      </p:nvGrpSpPr>
+      <p:grpSpPr>
+        <a:xfrm>
+          <a:off x="0" y="0"/>
+          <a:ext cx="0" cy="0"/>
+          <a:chOff x="0" y="0"/>
+          <a:chExt cx="0" cy="0"/>
+        </a:xfrm>
+      </p:grpSpPr>
+      <p:sp>
+        <p:nvSpPr>
+          <p:cNvPr id="477" name="Google Shape;477;ge04b8b6756_0_49:notes"/>
+          <p:cNvSpPr>
+            <a:spLocks noGrp="1" noRot="1" noChangeAspect="1"/>
+          </p:cNvSpPr>
+          <p:nvPr>
+            <p:ph type="sldImg" idx="2"/>
+          </p:nvPr>
+        </p:nvSpPr>
+        <p:spPr>
+          <a:xfrm>
+            <a:off x="381000" y="685800"/>
+            <a:ext cx="6096000" cy="3429000"/>
+          </a:xfrm>
+          <a:custGeom>
+            <a:avLst/>
+            <a:gdLst/>
+            <a:ahLst/>
+            <a:cxnLst/>
+            <a:rect l="l" t="t" r="r" b="b"/>
+            <a:pathLst>
+              <a:path w="120000" h="120000" extrusionOk="0">
+                <a:moveTo>
+                  <a:pt x="0" y="0"/>
+                </a:moveTo>
+                <a:lnTo>
+                  <a:pt x="120000" y="0"/>
+                </a:lnTo>
+                <a:lnTo>
+                  <a:pt x="120000" y="120000"/>
+                </a:lnTo>
+                <a:lnTo>
+                  <a:pt x="0" y="120000"/>
+                </a:lnTo>
+                <a:close/>
+              </a:path>
+            </a:pathLst>
+          </a:custGeom>
+        </p:spPr>
+      </p:sp>
+      <p:sp>
+        <p:nvSpPr>
+          <p:cNvPr id="478" name="Google Shape;478;ge04b8b6756_0_49:notes"/>
+          <p:cNvSpPr txBox="1">
+            <a:spLocks noGrp="1"/>
+          </p:cNvSpPr>
+          <p:nvPr>
+            <p:ph type="body" idx="1"/>
+          </p:nvPr>
+        </p:nvSpPr>
+        <p:spPr>
+          <a:xfrm>
+            <a:off x="685800" y="4343400"/>
+            <a:ext cx="5486400" cy="4114800"/>
+          </a:xfrm>
+          <a:prstGeom prst="rect">
+            <a:avLst/>
+          </a:prstGeom>
+        </p:spPr>
+        <p:txBody>
+          <a:bodyPr spcFirstLastPara="1" wrap="square" lIns="91425" tIns="91425" rIns="91425" bIns="91425" anchor="t" anchorCtr="0">
+            <a:noAutofit/>
+          </a:bodyPr>
+          <a:lstStyle/>
+          <a:p>
+            <a:pPr marL="0" lvl="0" indent="0" algn="l" rtl="0">
+              <a:spcBef>
+                <a:spcPts val="0"/>
+              </a:spcBef>
+              <a:spcAft>
+                <a:spcPts val="0"/>
+              </a:spcAft>
+              <a:buNone/>
+            </a:pPr>
+            <a:endParaRPr/>
+          </a:p>
+        </p:txBody>
+      </p:sp>
+    </p:spTree>
+  </p:cSld>
+  <p:clrMapOvr>
+    <a:masterClrMapping/>
+  </p:clrMapOvr>
+</p:notes>
+</file>
+
 <file path=ppt/notesSlides/notesSlide3.xml><?xml version="1.0" encoding="utf-8"?>
 <p:notes xmlns:a="http://schemas.openxmlformats.org/drawingml/2006/main" xmlns:r="http://schemas.openxmlformats.org/officeDocument/2006/relationships" xmlns:p="http://schemas.openxmlformats.org/presentationml/2006/main" showMasterSp="0" showMasterPhAnim="0">
   <p:cSld>
@@ -3188,110 +3072,6 @@
       <p:sp>
         <p:nvSpPr>
           <p:cNvPr id="212" name="Google Shape;212;gde823becd0_0_24:notes"/>
-          <p:cNvSpPr txBox="1">
-            <a:spLocks noGrp="1"/>
-          </p:cNvSpPr>
-          <p:nvPr>
-            <p:ph type="body" idx="1"/>
-          </p:nvPr>
-        </p:nvSpPr>
-        <p:spPr>
-          <a:xfrm>
-            <a:off x="685800" y="4343400"/>
-            <a:ext cx="5486400" cy="4114800"/>
-          </a:xfrm>
-          <a:prstGeom prst="rect">
-            <a:avLst/>
-          </a:prstGeom>
-        </p:spPr>
-        <p:txBody>
-          <a:bodyPr spcFirstLastPara="1" wrap="square" lIns="91425" tIns="91425" rIns="91425" bIns="91425" anchor="t" anchorCtr="0">
-            <a:noAutofit/>
-          </a:bodyPr>
-          <a:lstStyle/>
-          <a:p>
-            <a:pPr marL="0" lvl="0" indent="0" algn="l" rtl="0">
-              <a:spcBef>
-                <a:spcPts val="0"/>
-              </a:spcBef>
-              <a:spcAft>
-                <a:spcPts val="0"/>
-              </a:spcAft>
-              <a:buNone/>
-            </a:pPr>
-            <a:endParaRPr/>
-          </a:p>
-        </p:txBody>
-      </p:sp>
-    </p:spTree>
-  </p:cSld>
-  <p:clrMapOvr>
-    <a:masterClrMapping/>
-  </p:clrMapOvr>
-</p:notes>
-</file>
-
-<file path=ppt/notesSlides/notesSlide30.xml><?xml version="1.0" encoding="utf-8"?>
-<p:notes xmlns:a="http://schemas.openxmlformats.org/drawingml/2006/main" xmlns:r="http://schemas.openxmlformats.org/officeDocument/2006/relationships" xmlns:p="http://schemas.openxmlformats.org/presentationml/2006/main" showMasterSp="0" showMasterPhAnim="0">
-  <p:cSld>
-    <p:spTree>
-      <p:nvGrpSpPr>
-        <p:cNvPr id="1" name="Shape 476"/>
-        <p:cNvGrpSpPr/>
-        <p:nvPr/>
-      </p:nvGrpSpPr>
-      <p:grpSpPr>
-        <a:xfrm>
-          <a:off x="0" y="0"/>
-          <a:ext cx="0" cy="0"/>
-          <a:chOff x="0" y="0"/>
-          <a:chExt cx="0" cy="0"/>
-        </a:xfrm>
-      </p:grpSpPr>
-      <p:sp>
-        <p:nvSpPr>
-          <p:cNvPr id="477" name="Google Shape;477;ge04b8b6756_0_49:notes"/>
-          <p:cNvSpPr>
-            <a:spLocks noGrp="1" noRot="1" noChangeAspect="1"/>
-          </p:cNvSpPr>
-          <p:nvPr>
-            <p:ph type="sldImg" idx="2"/>
-          </p:nvPr>
-        </p:nvSpPr>
-        <p:spPr>
-          <a:xfrm>
-            <a:off x="381000" y="685800"/>
-            <a:ext cx="6096000" cy="3429000"/>
-          </a:xfrm>
-          <a:custGeom>
-            <a:avLst/>
-            <a:gdLst/>
-            <a:ahLst/>
-            <a:cxnLst/>
-            <a:rect l="l" t="t" r="r" b="b"/>
-            <a:pathLst>
-              <a:path w="120000" h="120000" extrusionOk="0">
-                <a:moveTo>
-                  <a:pt x="0" y="0"/>
-                </a:moveTo>
-                <a:lnTo>
-                  <a:pt x="120000" y="0"/>
-                </a:lnTo>
-                <a:lnTo>
-                  <a:pt x="120000" y="120000"/>
-                </a:lnTo>
-                <a:lnTo>
-                  <a:pt x="0" y="120000"/>
-                </a:lnTo>
-                <a:close/>
-              </a:path>
-            </a:pathLst>
-          </a:custGeom>
-        </p:spPr>
-      </p:sp>
-      <p:sp>
-        <p:nvSpPr>
-          <p:cNvPr id="478" name="Google Shape;478;ge04b8b6756_0_49:notes"/>
           <p:cNvSpPr txBox="1">
             <a:spLocks noGrp="1"/>
           </p:cNvSpPr>
@@ -19522,259 +19302,6 @@
         <p:spPr>
           <a:xfrm>
             <a:off x="500550" y="330724"/>
-            <a:ext cx="7777495" cy="1095900"/>
-          </a:xfrm>
-          <a:prstGeom prst="rect">
-            <a:avLst/>
-          </a:prstGeom>
-        </p:spPr>
-        <p:txBody>
-          <a:bodyPr spcFirstLastPara="1" wrap="square" lIns="91425" tIns="91425" rIns="91425" bIns="91425" anchor="t" anchorCtr="0">
-            <a:noAutofit/>
-          </a:bodyPr>
-          <a:lstStyle/>
-          <a:p>
-            <a:pPr algn="ctr"/>
-            <a:r>
-              <a:rPr lang="ru-RU" dirty="0">
-                <a:solidFill>
-                  <a:srgbClr val="058D40"/>
-                </a:solidFill>
-                <a:latin typeface="Helvetica Neue" panose="02000503000000020004" pitchFamily="2" charset="0"/>
-              </a:rPr>
-              <a:t>достоинства</a:t>
-            </a:r>
-            <a:r>
-              <a:rPr lang="ru-RU" dirty="0">
-                <a:solidFill>
-                  <a:srgbClr val="000000"/>
-                </a:solidFill>
-                <a:latin typeface="Helvetica Neue" panose="02000503000000020004" pitchFamily="2" charset="0"/>
-              </a:rPr>
-              <a:t> и </a:t>
-            </a:r>
-            <a:r>
-              <a:rPr lang="ru-RU" dirty="0">
-                <a:solidFill>
-                  <a:srgbClr val="C00000"/>
-                </a:solidFill>
-                <a:latin typeface="Helvetica Neue" panose="02000503000000020004" pitchFamily="2" charset="0"/>
-              </a:rPr>
-              <a:t>недостатки</a:t>
-            </a:r>
-            <a:endParaRPr dirty="0">
-              <a:solidFill>
-                <a:srgbClr val="C00000"/>
-              </a:solidFill>
-            </a:endParaRPr>
-          </a:p>
-        </p:txBody>
-      </p:sp>
-      <p:pic>
-        <p:nvPicPr>
-          <p:cNvPr id="5" name="Picture 4">
-            <a:extLst>
-              <a:ext uri="{FF2B5EF4-FFF2-40B4-BE49-F238E27FC236}">
-                <a16:creationId xmlns:a16="http://schemas.microsoft.com/office/drawing/2014/main" id="{9E712291-7ABD-834A-95A3-323BA7CC4C03}"/>
-              </a:ext>
-            </a:extLst>
-          </p:cNvPr>
-          <p:cNvPicPr>
-            <a:picLocks noChangeAspect="1"/>
-          </p:cNvPicPr>
-          <p:nvPr/>
-        </p:nvPicPr>
-        <p:blipFill>
-          <a:blip r:embed="rId3"/>
-          <a:stretch>
-            <a:fillRect/>
-          </a:stretch>
-        </p:blipFill>
-        <p:spPr>
-          <a:xfrm>
-            <a:off x="2843193" y="1259260"/>
-            <a:ext cx="3496698" cy="3110221"/>
-          </a:xfrm>
-          <a:prstGeom prst="rect">
-            <a:avLst/>
-          </a:prstGeom>
-        </p:spPr>
-      </p:pic>
-      <p:sp>
-        <p:nvSpPr>
-          <p:cNvPr id="8" name="Rectangle 7">
-            <a:extLst>
-              <a:ext uri="{FF2B5EF4-FFF2-40B4-BE49-F238E27FC236}">
-                <a16:creationId xmlns:a16="http://schemas.microsoft.com/office/drawing/2014/main" id="{93B2C0E7-6CD8-1445-AE87-37F092D54C9D}"/>
-              </a:ext>
-            </a:extLst>
-          </p:cNvPr>
-          <p:cNvSpPr/>
-          <p:nvPr/>
-        </p:nvSpPr>
-        <p:spPr>
-          <a:xfrm>
-            <a:off x="2843193" y="3540999"/>
-            <a:ext cx="1188759" cy="331393"/>
-          </a:xfrm>
-          <a:prstGeom prst="rect">
-            <a:avLst/>
-          </a:prstGeom>
-          <a:solidFill>
-            <a:schemeClr val="bg1"/>
-          </a:solidFill>
-          <a:ln>
-            <a:solidFill>
-              <a:schemeClr val="bg1"/>
-            </a:solidFill>
-          </a:ln>
-        </p:spPr>
-        <p:style>
-          <a:lnRef idx="2">
-            <a:schemeClr val="accent1">
-              <a:shade val="50000"/>
-            </a:schemeClr>
-          </a:lnRef>
-          <a:fillRef idx="1">
-            <a:schemeClr val="accent1"/>
-          </a:fillRef>
-          <a:effectRef idx="0">
-            <a:schemeClr val="accent1"/>
-          </a:effectRef>
-          <a:fontRef idx="minor">
-            <a:schemeClr val="lt1"/>
-          </a:fontRef>
-        </p:style>
-        <p:txBody>
-          <a:bodyPr rtlCol="0" anchor="ctr"/>
-          <a:lstStyle/>
-          <a:p>
-            <a:pPr algn="ctr"/>
-            <a:r>
-              <a:rPr lang="en-US" dirty="0">
-                <a:solidFill>
-                  <a:srgbClr val="058D40"/>
-                </a:solidFill>
-              </a:rPr>
-              <a:t>Advantages</a:t>
-            </a:r>
-            <a:endParaRPr lang="en-RU" dirty="0">
-              <a:solidFill>
-                <a:srgbClr val="058D40"/>
-              </a:solidFill>
-            </a:endParaRPr>
-          </a:p>
-        </p:txBody>
-      </p:sp>
-      <p:sp>
-        <p:nvSpPr>
-          <p:cNvPr id="11" name="Rectangle 10">
-            <a:extLst>
-              <a:ext uri="{FF2B5EF4-FFF2-40B4-BE49-F238E27FC236}">
-                <a16:creationId xmlns:a16="http://schemas.microsoft.com/office/drawing/2014/main" id="{B8D86B4B-9083-7143-BCF3-5EDCF81A9773}"/>
-              </a:ext>
-            </a:extLst>
-          </p:cNvPr>
-          <p:cNvSpPr/>
-          <p:nvPr/>
-        </p:nvSpPr>
-        <p:spPr>
-          <a:xfrm>
-            <a:off x="4928721" y="3010905"/>
-            <a:ext cx="1411170" cy="331393"/>
-          </a:xfrm>
-          <a:prstGeom prst="rect">
-            <a:avLst/>
-          </a:prstGeom>
-          <a:solidFill>
-            <a:schemeClr val="bg1"/>
-          </a:solidFill>
-          <a:ln>
-            <a:solidFill>
-              <a:schemeClr val="bg1"/>
-            </a:solidFill>
-          </a:ln>
-        </p:spPr>
-        <p:style>
-          <a:lnRef idx="2">
-            <a:schemeClr val="accent1">
-              <a:shade val="50000"/>
-            </a:schemeClr>
-          </a:lnRef>
-          <a:fillRef idx="1">
-            <a:schemeClr val="accent1"/>
-          </a:fillRef>
-          <a:effectRef idx="0">
-            <a:schemeClr val="accent1"/>
-          </a:effectRef>
-          <a:fontRef idx="minor">
-            <a:schemeClr val="lt1"/>
-          </a:fontRef>
-        </p:style>
-        <p:txBody>
-          <a:bodyPr rtlCol="0" anchor="ctr"/>
-          <a:lstStyle/>
-          <a:p>
-            <a:pPr algn="ctr"/>
-            <a:r>
-              <a:rPr lang="en-US" dirty="0">
-                <a:solidFill>
-                  <a:srgbClr val="C00000"/>
-                </a:solidFill>
-              </a:rPr>
-              <a:t>Disadvantages</a:t>
-            </a:r>
-            <a:endParaRPr lang="en-RU" dirty="0">
-              <a:solidFill>
-                <a:srgbClr val="C00000"/>
-              </a:solidFill>
-            </a:endParaRPr>
-          </a:p>
-        </p:txBody>
-      </p:sp>
-    </p:spTree>
-    <p:extLst>
-      <p:ext uri="{BB962C8B-B14F-4D97-AF65-F5344CB8AC3E}">
-        <p14:creationId xmlns:p14="http://schemas.microsoft.com/office/powerpoint/2010/main" val="2202594289"/>
-      </p:ext>
-    </p:extLst>
-  </p:cSld>
-  <p:clrMapOvr>
-    <a:masterClrMapping/>
-  </p:clrMapOvr>
-</p:sld>
-</file>
-
-<file path=ppt/slides/slide14.xml><?xml version="1.0" encoding="utf-8"?>
-<p:sld xmlns:a="http://schemas.openxmlformats.org/drawingml/2006/main" xmlns:r="http://schemas.openxmlformats.org/officeDocument/2006/relationships" xmlns:p="http://schemas.openxmlformats.org/presentationml/2006/main">
-  <p:cSld>
-    <p:spTree>
-      <p:nvGrpSpPr>
-        <p:cNvPr id="1" name="Shape 309"/>
-        <p:cNvGrpSpPr/>
-        <p:nvPr/>
-      </p:nvGrpSpPr>
-      <p:grpSpPr>
-        <a:xfrm>
-          <a:off x="0" y="0"/>
-          <a:ext cx="0" cy="0"/>
-          <a:chOff x="0" y="0"/>
-          <a:chExt cx="0" cy="0"/>
-        </a:xfrm>
-      </p:grpSpPr>
-      <p:sp>
-        <p:nvSpPr>
-          <p:cNvPr id="310" name="Google Shape;310;p57"/>
-          <p:cNvSpPr txBox="1">
-            <a:spLocks noGrp="1"/>
-          </p:cNvSpPr>
-          <p:nvPr>
-            <p:ph type="title"/>
-          </p:nvPr>
-        </p:nvSpPr>
-        <p:spPr>
-          <a:xfrm>
-            <a:off x="500550" y="330724"/>
             <a:ext cx="8520600" cy="1095900"/>
           </a:xfrm>
           <a:prstGeom prst="rect">
@@ -20295,7 +19822,7 @@
 </p:sld>
 </file>
 
-<file path=ppt/slides/slide15.xml><?xml version="1.0" encoding="utf-8"?>
+<file path=ppt/slides/slide14.xml><?xml version="1.0" encoding="utf-8"?>
 <p:sld xmlns:a="http://schemas.openxmlformats.org/drawingml/2006/main" xmlns:r="http://schemas.openxmlformats.org/officeDocument/2006/relationships" xmlns:p="http://schemas.openxmlformats.org/presentationml/2006/main">
   <p:cSld>
     <p:spTree>
@@ -21069,7 +20596,7 @@
 </p:sld>
 </file>
 
-<file path=ppt/slides/slide16.xml><?xml version="1.0" encoding="utf-8"?>
+<file path=ppt/slides/slide15.xml><?xml version="1.0" encoding="utf-8"?>
 <p:sld xmlns:a="http://schemas.openxmlformats.org/drawingml/2006/main" xmlns:r="http://schemas.openxmlformats.org/officeDocument/2006/relationships" xmlns:p="http://schemas.openxmlformats.org/presentationml/2006/main">
   <p:cSld>
     <p:spTree>
@@ -22327,7 +21854,7 @@
 </p:sld>
 </file>
 
-<file path=ppt/slides/slide17.xml><?xml version="1.0" encoding="utf-8"?>
+<file path=ppt/slides/slide16.xml><?xml version="1.0" encoding="utf-8"?>
 <p:sld xmlns:a="http://schemas.openxmlformats.org/drawingml/2006/main" xmlns:r="http://schemas.openxmlformats.org/officeDocument/2006/relationships" xmlns:p="http://schemas.openxmlformats.org/presentationml/2006/main">
   <p:cSld>
     <p:spTree>
@@ -23367,7 +22894,7 @@
 </p:sld>
 </file>
 
-<file path=ppt/slides/slide18.xml><?xml version="1.0" encoding="utf-8"?>
+<file path=ppt/slides/slide17.xml><?xml version="1.0" encoding="utf-8"?>
 <p:sld xmlns:a="http://schemas.openxmlformats.org/drawingml/2006/main" xmlns:r="http://schemas.openxmlformats.org/officeDocument/2006/relationships" xmlns:p="http://schemas.openxmlformats.org/presentationml/2006/main">
   <p:cSld>
     <p:spTree>
@@ -23448,7 +22975,7 @@
 </p:sld>
 </file>
 
-<file path=ppt/slides/slide19.xml><?xml version="1.0" encoding="utf-8"?>
+<file path=ppt/slides/slide18.xml><?xml version="1.0" encoding="utf-8"?>
 <p:sld xmlns:a="http://schemas.openxmlformats.org/drawingml/2006/main" xmlns:r="http://schemas.openxmlformats.org/officeDocument/2006/relationships" xmlns:p="http://schemas.openxmlformats.org/presentationml/2006/main">
   <p:cSld>
     <p:spTree>
@@ -23868,272 +23395,7 @@
 </p:sld>
 </file>
 
-<file path=ppt/slides/slide2.xml><?xml version="1.0" encoding="utf-8"?>
-<p:sld xmlns:a="http://schemas.openxmlformats.org/drawingml/2006/main" xmlns:r="http://schemas.openxmlformats.org/officeDocument/2006/relationships" xmlns:p="http://schemas.openxmlformats.org/presentationml/2006/main">
-  <p:cSld>
-    <p:spTree>
-      <p:nvGrpSpPr>
-        <p:cNvPr id="1" name="Shape 194"/>
-        <p:cNvGrpSpPr/>
-        <p:nvPr/>
-      </p:nvGrpSpPr>
-      <p:grpSpPr>
-        <a:xfrm>
-          <a:off x="0" y="0"/>
-          <a:ext cx="0" cy="0"/>
-          <a:chOff x="0" y="0"/>
-          <a:chExt cx="0" cy="0"/>
-        </a:xfrm>
-      </p:grpSpPr>
-      <p:sp>
-        <p:nvSpPr>
-          <p:cNvPr id="195" name="Google Shape;195;p47"/>
-          <p:cNvSpPr txBox="1">
-            <a:spLocks noGrp="1"/>
-          </p:cNvSpPr>
-          <p:nvPr>
-            <p:ph type="title"/>
-          </p:nvPr>
-        </p:nvSpPr>
-        <p:spPr>
-          <a:xfrm>
-            <a:off x="1635875" y="772125"/>
-            <a:ext cx="7935300" cy="841800"/>
-          </a:xfrm>
-          <a:prstGeom prst="rect">
-            <a:avLst/>
-          </a:prstGeom>
-        </p:spPr>
-        <p:txBody>
-          <a:bodyPr spcFirstLastPara="1" wrap="square" lIns="91425" tIns="91425" rIns="91425" bIns="91425" anchor="ctr" anchorCtr="0">
-            <a:noAutofit/>
-          </a:bodyPr>
-          <a:lstStyle/>
-          <a:p>
-            <a:pPr marL="0" lvl="0" indent="0" algn="l" rtl="0">
-              <a:spcBef>
-                <a:spcPts val="0"/>
-              </a:spcBef>
-              <a:spcAft>
-                <a:spcPts val="0"/>
-              </a:spcAft>
-              <a:buNone/>
-            </a:pPr>
-            <a:r>
-              <a:rPr lang="ru" sz="2100"/>
-              <a:t>Проверить, идет ли запись</a:t>
-            </a:r>
-            <a:endParaRPr sz="2100"/>
-          </a:p>
-        </p:txBody>
-      </p:sp>
-      <p:sp>
-        <p:nvSpPr>
-          <p:cNvPr id="196" name="Google Shape;196;p47"/>
-          <p:cNvSpPr txBox="1">
-            <a:spLocks noGrp="1"/>
-          </p:cNvSpPr>
-          <p:nvPr>
-            <p:ph type="title"/>
-          </p:nvPr>
-        </p:nvSpPr>
-        <p:spPr>
-          <a:xfrm>
-            <a:off x="766725" y="1805199"/>
-            <a:ext cx="7935300" cy="1295700"/>
-          </a:xfrm>
-          <a:prstGeom prst="rect">
-            <a:avLst/>
-          </a:prstGeom>
-        </p:spPr>
-        <p:txBody>
-          <a:bodyPr spcFirstLastPara="1" wrap="square" lIns="91425" tIns="91425" rIns="91425" bIns="91425" anchor="ctr" anchorCtr="0">
-            <a:noAutofit/>
-          </a:bodyPr>
-          <a:lstStyle/>
-          <a:p>
-            <a:pPr marL="0" lvl="0" indent="0" algn="l" rtl="0">
-              <a:spcBef>
-                <a:spcPts val="0"/>
-              </a:spcBef>
-              <a:spcAft>
-                <a:spcPts val="0"/>
-              </a:spcAft>
-              <a:buClr>
-                <a:schemeClr val="dk1"/>
-              </a:buClr>
-              <a:buSzPts val="1100"/>
-              <a:buFont typeface="Arial"/>
-              <a:buNone/>
-            </a:pPr>
-            <a:r>
-              <a:rPr lang="ru" sz="4000"/>
-              <a:t>Меня хорошо видно</a:t>
-            </a:r>
-            <a:endParaRPr sz="4000"/>
-          </a:p>
-          <a:p>
-            <a:pPr marL="0" lvl="0" indent="0" algn="l" rtl="0">
-              <a:spcBef>
-                <a:spcPts val="0"/>
-              </a:spcBef>
-              <a:spcAft>
-                <a:spcPts val="0"/>
-              </a:spcAft>
-              <a:buNone/>
-            </a:pPr>
-            <a:r>
-              <a:rPr lang="ru" sz="4000"/>
-              <a:t>&amp;&amp; слышно?</a:t>
-            </a:r>
-            <a:endParaRPr sz="4000"/>
-          </a:p>
-        </p:txBody>
-      </p:sp>
-      <p:pic>
-        <p:nvPicPr>
-          <p:cNvPr id="197" name="Google Shape;197;p47"/>
-          <p:cNvPicPr preferRelativeResize="0"/>
-          <p:nvPr/>
-        </p:nvPicPr>
-        <p:blipFill rotWithShape="1">
-          <a:blip r:embed="rId3">
-            <a:alphaModFix/>
-          </a:blip>
-          <a:srcRect l="99" r="99"/>
-          <a:stretch/>
-        </p:blipFill>
-        <p:spPr>
-          <a:xfrm>
-            <a:off x="880825" y="1032408"/>
-            <a:ext cx="642317" cy="321159"/>
-          </a:xfrm>
-          <a:prstGeom prst="rect">
-            <a:avLst/>
-          </a:prstGeom>
-          <a:noFill/>
-          <a:ln>
-            <a:noFill/>
-          </a:ln>
-        </p:spPr>
-      </p:pic>
-      <p:pic>
-        <p:nvPicPr>
-          <p:cNvPr id="198" name="Google Shape;198;p47"/>
-          <p:cNvPicPr preferRelativeResize="0"/>
-          <p:nvPr/>
-        </p:nvPicPr>
-        <p:blipFill rotWithShape="1">
-          <a:blip r:embed="rId4">
-            <a:alphaModFix/>
-          </a:blip>
-          <a:srcRect/>
-          <a:stretch/>
-        </p:blipFill>
-        <p:spPr>
-          <a:xfrm>
-            <a:off x="872375" y="3520050"/>
-            <a:ext cx="525600" cy="525600"/>
-          </a:xfrm>
-          <a:prstGeom prst="rect">
-            <a:avLst/>
-          </a:prstGeom>
-          <a:noFill/>
-          <a:ln>
-            <a:noFill/>
-          </a:ln>
-        </p:spPr>
-      </p:pic>
-      <p:sp>
-        <p:nvSpPr>
-          <p:cNvPr id="199" name="Google Shape;199;p47"/>
-          <p:cNvSpPr txBox="1"/>
-          <p:nvPr/>
-        </p:nvSpPr>
-        <p:spPr>
-          <a:xfrm>
-            <a:off x="1514225" y="3459600"/>
-            <a:ext cx="3000000" cy="646500"/>
-          </a:xfrm>
-          <a:prstGeom prst="rect">
-            <a:avLst/>
-          </a:prstGeom>
-          <a:noFill/>
-          <a:ln>
-            <a:noFill/>
-          </a:ln>
-        </p:spPr>
-        <p:txBody>
-          <a:bodyPr spcFirstLastPara="1" wrap="square" lIns="91425" tIns="91425" rIns="91425" bIns="91425" anchor="t" anchorCtr="0">
-            <a:spAutoFit/>
-          </a:bodyPr>
-          <a:lstStyle/>
-          <a:p>
-            <a:pPr marL="0" lvl="0" indent="0" algn="l" rtl="0">
-              <a:spcBef>
-                <a:spcPts val="0"/>
-              </a:spcBef>
-              <a:spcAft>
-                <a:spcPts val="0"/>
-              </a:spcAft>
-              <a:buNone/>
-            </a:pPr>
-            <a:r>
-              <a:rPr lang="ru" sz="1500">
-                <a:solidFill>
-                  <a:schemeClr val="dk1"/>
-                </a:solidFill>
-                <a:latin typeface="Roboto"/>
-                <a:ea typeface="Roboto"/>
-                <a:cs typeface="Roboto"/>
-                <a:sym typeface="Roboto"/>
-              </a:rPr>
-              <a:t>Ставим “+”, если все хорошо</a:t>
-            </a:r>
-            <a:br>
-              <a:rPr lang="ru" sz="1500">
-                <a:solidFill>
-                  <a:schemeClr val="dk1"/>
-                </a:solidFill>
-                <a:latin typeface="Roboto"/>
-                <a:ea typeface="Roboto"/>
-                <a:cs typeface="Roboto"/>
-                <a:sym typeface="Roboto"/>
-              </a:rPr>
-            </a:br>
-            <a:r>
-              <a:rPr lang="ru" sz="1500">
-                <a:solidFill>
-                  <a:schemeClr val="dk1"/>
-                </a:solidFill>
-                <a:latin typeface="Roboto"/>
-                <a:ea typeface="Roboto"/>
-                <a:cs typeface="Roboto"/>
-                <a:sym typeface="Roboto"/>
-              </a:rPr>
-              <a:t>“-”, если есть проблемы</a:t>
-            </a:r>
-            <a:endParaRPr sz="1500">
-              <a:solidFill>
-                <a:schemeClr val="dk1"/>
-              </a:solidFill>
-              <a:latin typeface="Roboto"/>
-              <a:ea typeface="Roboto"/>
-              <a:cs typeface="Roboto"/>
-              <a:sym typeface="Roboto"/>
-            </a:endParaRPr>
-          </a:p>
-        </p:txBody>
-      </p:sp>
-    </p:spTree>
-  </p:cSld>
-  <p:clrMapOvr>
-    <a:masterClrMapping/>
-  </p:clrMapOvr>
-</p:sld>
-</file>
-
-<file path=ppt/slides/slide20.xml><?xml version="1.0" encoding="utf-8"?>
+<file path=ppt/slides/slide19.xml><?xml version="1.0" encoding="utf-8"?>
 <p:sld xmlns:a="http://schemas.openxmlformats.org/drawingml/2006/main" xmlns:r="http://schemas.openxmlformats.org/officeDocument/2006/relationships" xmlns:p="http://schemas.openxmlformats.org/presentationml/2006/main">
   <p:cSld>
     <p:spTree>
@@ -25209,7 +24471,272 @@
 </p:sld>
 </file>
 
-<file path=ppt/slides/slide21.xml><?xml version="1.0" encoding="utf-8"?>
+<file path=ppt/slides/slide2.xml><?xml version="1.0" encoding="utf-8"?>
+<p:sld xmlns:a="http://schemas.openxmlformats.org/drawingml/2006/main" xmlns:r="http://schemas.openxmlformats.org/officeDocument/2006/relationships" xmlns:p="http://schemas.openxmlformats.org/presentationml/2006/main">
+  <p:cSld>
+    <p:spTree>
+      <p:nvGrpSpPr>
+        <p:cNvPr id="1" name="Shape 194"/>
+        <p:cNvGrpSpPr/>
+        <p:nvPr/>
+      </p:nvGrpSpPr>
+      <p:grpSpPr>
+        <a:xfrm>
+          <a:off x="0" y="0"/>
+          <a:ext cx="0" cy="0"/>
+          <a:chOff x="0" y="0"/>
+          <a:chExt cx="0" cy="0"/>
+        </a:xfrm>
+      </p:grpSpPr>
+      <p:sp>
+        <p:nvSpPr>
+          <p:cNvPr id="195" name="Google Shape;195;p47"/>
+          <p:cNvSpPr txBox="1">
+            <a:spLocks noGrp="1"/>
+          </p:cNvSpPr>
+          <p:nvPr>
+            <p:ph type="title"/>
+          </p:nvPr>
+        </p:nvSpPr>
+        <p:spPr>
+          <a:xfrm>
+            <a:off x="1635875" y="772125"/>
+            <a:ext cx="7935300" cy="841800"/>
+          </a:xfrm>
+          <a:prstGeom prst="rect">
+            <a:avLst/>
+          </a:prstGeom>
+        </p:spPr>
+        <p:txBody>
+          <a:bodyPr spcFirstLastPara="1" wrap="square" lIns="91425" tIns="91425" rIns="91425" bIns="91425" anchor="ctr" anchorCtr="0">
+            <a:noAutofit/>
+          </a:bodyPr>
+          <a:lstStyle/>
+          <a:p>
+            <a:pPr marL="0" lvl="0" indent="0" algn="l" rtl="0">
+              <a:spcBef>
+                <a:spcPts val="0"/>
+              </a:spcBef>
+              <a:spcAft>
+                <a:spcPts val="0"/>
+              </a:spcAft>
+              <a:buNone/>
+            </a:pPr>
+            <a:r>
+              <a:rPr lang="ru" sz="2100"/>
+              <a:t>Проверить, идет ли запись</a:t>
+            </a:r>
+            <a:endParaRPr sz="2100"/>
+          </a:p>
+        </p:txBody>
+      </p:sp>
+      <p:sp>
+        <p:nvSpPr>
+          <p:cNvPr id="196" name="Google Shape;196;p47"/>
+          <p:cNvSpPr txBox="1">
+            <a:spLocks noGrp="1"/>
+          </p:cNvSpPr>
+          <p:nvPr>
+            <p:ph type="title"/>
+          </p:nvPr>
+        </p:nvSpPr>
+        <p:spPr>
+          <a:xfrm>
+            <a:off x="766725" y="1805199"/>
+            <a:ext cx="7935300" cy="1295700"/>
+          </a:xfrm>
+          <a:prstGeom prst="rect">
+            <a:avLst/>
+          </a:prstGeom>
+        </p:spPr>
+        <p:txBody>
+          <a:bodyPr spcFirstLastPara="1" wrap="square" lIns="91425" tIns="91425" rIns="91425" bIns="91425" anchor="ctr" anchorCtr="0">
+            <a:noAutofit/>
+          </a:bodyPr>
+          <a:lstStyle/>
+          <a:p>
+            <a:pPr marL="0" lvl="0" indent="0" algn="l" rtl="0">
+              <a:spcBef>
+                <a:spcPts val="0"/>
+              </a:spcBef>
+              <a:spcAft>
+                <a:spcPts val="0"/>
+              </a:spcAft>
+              <a:buClr>
+                <a:schemeClr val="dk1"/>
+              </a:buClr>
+              <a:buSzPts val="1100"/>
+              <a:buFont typeface="Arial"/>
+              <a:buNone/>
+            </a:pPr>
+            <a:r>
+              <a:rPr lang="ru" sz="4000"/>
+              <a:t>Меня хорошо видно</a:t>
+            </a:r>
+            <a:endParaRPr sz="4000"/>
+          </a:p>
+          <a:p>
+            <a:pPr marL="0" lvl="0" indent="0" algn="l" rtl="0">
+              <a:spcBef>
+                <a:spcPts val="0"/>
+              </a:spcBef>
+              <a:spcAft>
+                <a:spcPts val="0"/>
+              </a:spcAft>
+              <a:buNone/>
+            </a:pPr>
+            <a:r>
+              <a:rPr lang="ru" sz="4000"/>
+              <a:t>&amp;&amp; слышно?</a:t>
+            </a:r>
+            <a:endParaRPr sz="4000"/>
+          </a:p>
+        </p:txBody>
+      </p:sp>
+      <p:pic>
+        <p:nvPicPr>
+          <p:cNvPr id="197" name="Google Shape;197;p47"/>
+          <p:cNvPicPr preferRelativeResize="0"/>
+          <p:nvPr/>
+        </p:nvPicPr>
+        <p:blipFill rotWithShape="1">
+          <a:blip r:embed="rId3">
+            <a:alphaModFix/>
+          </a:blip>
+          <a:srcRect l="99" r="99"/>
+          <a:stretch/>
+        </p:blipFill>
+        <p:spPr>
+          <a:xfrm>
+            <a:off x="880825" y="1032408"/>
+            <a:ext cx="642317" cy="321159"/>
+          </a:xfrm>
+          <a:prstGeom prst="rect">
+            <a:avLst/>
+          </a:prstGeom>
+          <a:noFill/>
+          <a:ln>
+            <a:noFill/>
+          </a:ln>
+        </p:spPr>
+      </p:pic>
+      <p:pic>
+        <p:nvPicPr>
+          <p:cNvPr id="198" name="Google Shape;198;p47"/>
+          <p:cNvPicPr preferRelativeResize="0"/>
+          <p:nvPr/>
+        </p:nvPicPr>
+        <p:blipFill rotWithShape="1">
+          <a:blip r:embed="rId4">
+            <a:alphaModFix/>
+          </a:blip>
+          <a:srcRect/>
+          <a:stretch/>
+        </p:blipFill>
+        <p:spPr>
+          <a:xfrm>
+            <a:off x="872375" y="3520050"/>
+            <a:ext cx="525600" cy="525600"/>
+          </a:xfrm>
+          <a:prstGeom prst="rect">
+            <a:avLst/>
+          </a:prstGeom>
+          <a:noFill/>
+          <a:ln>
+            <a:noFill/>
+          </a:ln>
+        </p:spPr>
+      </p:pic>
+      <p:sp>
+        <p:nvSpPr>
+          <p:cNvPr id="199" name="Google Shape;199;p47"/>
+          <p:cNvSpPr txBox="1"/>
+          <p:nvPr/>
+        </p:nvSpPr>
+        <p:spPr>
+          <a:xfrm>
+            <a:off x="1514225" y="3459600"/>
+            <a:ext cx="3000000" cy="646500"/>
+          </a:xfrm>
+          <a:prstGeom prst="rect">
+            <a:avLst/>
+          </a:prstGeom>
+          <a:noFill/>
+          <a:ln>
+            <a:noFill/>
+          </a:ln>
+        </p:spPr>
+        <p:txBody>
+          <a:bodyPr spcFirstLastPara="1" wrap="square" lIns="91425" tIns="91425" rIns="91425" bIns="91425" anchor="t" anchorCtr="0">
+            <a:spAutoFit/>
+          </a:bodyPr>
+          <a:lstStyle/>
+          <a:p>
+            <a:pPr marL="0" lvl="0" indent="0" algn="l" rtl="0">
+              <a:spcBef>
+                <a:spcPts val="0"/>
+              </a:spcBef>
+              <a:spcAft>
+                <a:spcPts val="0"/>
+              </a:spcAft>
+              <a:buNone/>
+            </a:pPr>
+            <a:r>
+              <a:rPr lang="ru" sz="1500">
+                <a:solidFill>
+                  <a:schemeClr val="dk1"/>
+                </a:solidFill>
+                <a:latin typeface="Roboto"/>
+                <a:ea typeface="Roboto"/>
+                <a:cs typeface="Roboto"/>
+                <a:sym typeface="Roboto"/>
+              </a:rPr>
+              <a:t>Ставим “+”, если все хорошо</a:t>
+            </a:r>
+            <a:br>
+              <a:rPr lang="ru" sz="1500">
+                <a:solidFill>
+                  <a:schemeClr val="dk1"/>
+                </a:solidFill>
+                <a:latin typeface="Roboto"/>
+                <a:ea typeface="Roboto"/>
+                <a:cs typeface="Roboto"/>
+                <a:sym typeface="Roboto"/>
+              </a:rPr>
+            </a:br>
+            <a:r>
+              <a:rPr lang="ru" sz="1500">
+                <a:solidFill>
+                  <a:schemeClr val="dk1"/>
+                </a:solidFill>
+                <a:latin typeface="Roboto"/>
+                <a:ea typeface="Roboto"/>
+                <a:cs typeface="Roboto"/>
+                <a:sym typeface="Roboto"/>
+              </a:rPr>
+              <a:t>“-”, если есть проблемы</a:t>
+            </a:r>
+            <a:endParaRPr sz="1500">
+              <a:solidFill>
+                <a:schemeClr val="dk1"/>
+              </a:solidFill>
+              <a:latin typeface="Roboto"/>
+              <a:ea typeface="Roboto"/>
+              <a:cs typeface="Roboto"/>
+              <a:sym typeface="Roboto"/>
+            </a:endParaRPr>
+          </a:p>
+        </p:txBody>
+      </p:sp>
+    </p:spTree>
+  </p:cSld>
+  <p:clrMapOvr>
+    <a:masterClrMapping/>
+  </p:clrMapOvr>
+</p:sld>
+</file>
+
+<file path=ppt/slides/slide20.xml><?xml version="1.0" encoding="utf-8"?>
 <p:sld xmlns:a="http://schemas.openxmlformats.org/drawingml/2006/main" xmlns:r="http://schemas.openxmlformats.org/officeDocument/2006/relationships" xmlns:p="http://schemas.openxmlformats.org/presentationml/2006/main">
   <p:cSld>
     <p:spTree>
@@ -25293,7 +24820,7 @@
 </p:sld>
 </file>
 
-<file path=ppt/slides/slide22.xml><?xml version="1.0" encoding="utf-8"?>
+<file path=ppt/slides/slide21.xml><?xml version="1.0" encoding="utf-8"?>
 <p:sld xmlns:a="http://schemas.openxmlformats.org/drawingml/2006/main" xmlns:r="http://schemas.openxmlformats.org/officeDocument/2006/relationships" xmlns:p="http://schemas.openxmlformats.org/presentationml/2006/main">
   <p:cSld>
     <p:spTree>
@@ -26521,7 +26048,7 @@
 </p:sld>
 </file>
 
-<file path=ppt/slides/slide23.xml><?xml version="1.0" encoding="utf-8"?>
+<file path=ppt/slides/slide22.xml><?xml version="1.0" encoding="utf-8"?>
 <p:sld xmlns:a="http://schemas.openxmlformats.org/drawingml/2006/main" xmlns:r="http://schemas.openxmlformats.org/officeDocument/2006/relationships" xmlns:p="http://schemas.openxmlformats.org/presentationml/2006/main">
   <p:cSld>
     <p:spTree>
@@ -28161,7 +27688,7 @@
 </p:sld>
 </file>
 
-<file path=ppt/slides/slide24.xml><?xml version="1.0" encoding="utf-8"?>
+<file path=ppt/slides/slide23.xml><?xml version="1.0" encoding="utf-8"?>
 <p:sld xmlns:a="http://schemas.openxmlformats.org/drawingml/2006/main" xmlns:r="http://schemas.openxmlformats.org/officeDocument/2006/relationships" xmlns:p="http://schemas.openxmlformats.org/presentationml/2006/main">
   <p:cSld>
     <p:spTree>
@@ -30749,7 +30276,7 @@
 </p:sld>
 </file>
 
-<file path=ppt/slides/slide25.xml><?xml version="1.0" encoding="utf-8"?>
+<file path=ppt/slides/slide24.xml><?xml version="1.0" encoding="utf-8"?>
 <p:sld xmlns:a="http://schemas.openxmlformats.org/drawingml/2006/main" xmlns:r="http://schemas.openxmlformats.org/officeDocument/2006/relationships" xmlns:p="http://schemas.openxmlformats.org/presentationml/2006/main">
   <p:cSld>
     <p:spTree>
@@ -32133,260 +31660,7 @@
 </p:sld>
 </file>
 
-<file path=ppt/slides/slide26.xml><?xml version="1.0" encoding="utf-8"?>
-<p:sld xmlns:a="http://schemas.openxmlformats.org/drawingml/2006/main" xmlns:r="http://schemas.openxmlformats.org/officeDocument/2006/relationships" xmlns:p="http://schemas.openxmlformats.org/presentationml/2006/main">
-  <p:cSld>
-    <p:spTree>
-      <p:nvGrpSpPr>
-        <p:cNvPr id="1" name="Shape 309"/>
-        <p:cNvGrpSpPr/>
-        <p:nvPr/>
-      </p:nvGrpSpPr>
-      <p:grpSpPr>
-        <a:xfrm>
-          <a:off x="0" y="0"/>
-          <a:ext cx="0" cy="0"/>
-          <a:chOff x="0" y="0"/>
-          <a:chExt cx="0" cy="0"/>
-        </a:xfrm>
-      </p:grpSpPr>
-      <p:sp>
-        <p:nvSpPr>
-          <p:cNvPr id="310" name="Google Shape;310;p57"/>
-          <p:cNvSpPr txBox="1">
-            <a:spLocks noGrp="1"/>
-          </p:cNvSpPr>
-          <p:nvPr>
-            <p:ph type="title"/>
-          </p:nvPr>
-        </p:nvSpPr>
-        <p:spPr>
-          <a:xfrm>
-            <a:off x="500550" y="330724"/>
-            <a:ext cx="7777495" cy="1095900"/>
-          </a:xfrm>
-          <a:prstGeom prst="rect">
-            <a:avLst/>
-          </a:prstGeom>
-        </p:spPr>
-        <p:txBody>
-          <a:bodyPr spcFirstLastPara="1" wrap="square" lIns="91425" tIns="91425" rIns="91425" bIns="91425" anchor="t" anchorCtr="0">
-            <a:noAutofit/>
-          </a:bodyPr>
-          <a:lstStyle/>
-          <a:p>
-            <a:pPr algn="ctr"/>
-            <a:r>
-              <a:rPr lang="ru-RU" dirty="0">
-                <a:solidFill>
-                  <a:srgbClr val="058D40"/>
-                </a:solidFill>
-                <a:latin typeface="Helvetica Neue" panose="02000503000000020004" pitchFamily="2" charset="0"/>
-              </a:rPr>
-              <a:t>достоинства</a:t>
-            </a:r>
-            <a:r>
-              <a:rPr lang="ru-RU" dirty="0">
-                <a:solidFill>
-                  <a:srgbClr val="000000"/>
-                </a:solidFill>
-                <a:latin typeface="Helvetica Neue" panose="02000503000000020004" pitchFamily="2" charset="0"/>
-              </a:rPr>
-              <a:t> и </a:t>
-            </a:r>
-            <a:r>
-              <a:rPr lang="ru-RU" dirty="0">
-                <a:solidFill>
-                  <a:srgbClr val="C00000"/>
-                </a:solidFill>
-                <a:latin typeface="Helvetica Neue" panose="02000503000000020004" pitchFamily="2" charset="0"/>
-              </a:rPr>
-              <a:t>недостатки</a:t>
-            </a:r>
-            <a:endParaRPr dirty="0">
-              <a:solidFill>
-                <a:srgbClr val="C00000"/>
-              </a:solidFill>
-            </a:endParaRPr>
-          </a:p>
-        </p:txBody>
-      </p:sp>
-      <p:pic>
-        <p:nvPicPr>
-          <p:cNvPr id="5" name="Picture 4">
-            <a:extLst>
-              <a:ext uri="{FF2B5EF4-FFF2-40B4-BE49-F238E27FC236}">
-                <a16:creationId xmlns:a16="http://schemas.microsoft.com/office/drawing/2014/main" id="{9E712291-7ABD-834A-95A3-323BA7CC4C03}"/>
-              </a:ext>
-            </a:extLst>
-          </p:cNvPr>
-          <p:cNvPicPr>
-            <a:picLocks noChangeAspect="1"/>
-          </p:cNvPicPr>
-          <p:nvPr/>
-        </p:nvPicPr>
-        <p:blipFill>
-          <a:blip r:embed="rId3"/>
-          <a:stretch>
-            <a:fillRect/>
-          </a:stretch>
-        </p:blipFill>
-        <p:spPr>
-          <a:xfrm>
-            <a:off x="2843193" y="1259260"/>
-            <a:ext cx="3496698" cy="3110221"/>
-          </a:xfrm>
-          <a:prstGeom prst="rect">
-            <a:avLst/>
-          </a:prstGeom>
-        </p:spPr>
-      </p:pic>
-      <p:sp>
-        <p:nvSpPr>
-          <p:cNvPr id="8" name="Rectangle 7">
-            <a:extLst>
-              <a:ext uri="{FF2B5EF4-FFF2-40B4-BE49-F238E27FC236}">
-                <a16:creationId xmlns:a16="http://schemas.microsoft.com/office/drawing/2014/main" id="{93B2C0E7-6CD8-1445-AE87-37F092D54C9D}"/>
-              </a:ext>
-            </a:extLst>
-          </p:cNvPr>
-          <p:cNvSpPr/>
-          <p:nvPr/>
-        </p:nvSpPr>
-        <p:spPr>
-          <a:xfrm>
-            <a:off x="2843193" y="3540999"/>
-            <a:ext cx="1188759" cy="331393"/>
-          </a:xfrm>
-          <a:prstGeom prst="rect">
-            <a:avLst/>
-          </a:prstGeom>
-          <a:solidFill>
-            <a:schemeClr val="bg1"/>
-          </a:solidFill>
-          <a:ln>
-            <a:solidFill>
-              <a:schemeClr val="bg1"/>
-            </a:solidFill>
-          </a:ln>
-        </p:spPr>
-        <p:style>
-          <a:lnRef idx="2">
-            <a:schemeClr val="accent1">
-              <a:shade val="50000"/>
-            </a:schemeClr>
-          </a:lnRef>
-          <a:fillRef idx="1">
-            <a:schemeClr val="accent1"/>
-          </a:fillRef>
-          <a:effectRef idx="0">
-            <a:schemeClr val="accent1"/>
-          </a:effectRef>
-          <a:fontRef idx="minor">
-            <a:schemeClr val="lt1"/>
-          </a:fontRef>
-        </p:style>
-        <p:txBody>
-          <a:bodyPr rtlCol="0" anchor="ctr"/>
-          <a:lstStyle/>
-          <a:p>
-            <a:pPr algn="ctr"/>
-            <a:r>
-              <a:rPr lang="en-US" dirty="0">
-                <a:solidFill>
-                  <a:srgbClr val="058D40"/>
-                </a:solidFill>
-              </a:rPr>
-              <a:t>Advantages</a:t>
-            </a:r>
-            <a:endParaRPr lang="en-RU" dirty="0">
-              <a:solidFill>
-                <a:srgbClr val="058D40"/>
-              </a:solidFill>
-            </a:endParaRPr>
-          </a:p>
-        </p:txBody>
-      </p:sp>
-      <p:sp>
-        <p:nvSpPr>
-          <p:cNvPr id="11" name="Rectangle 10">
-            <a:extLst>
-              <a:ext uri="{FF2B5EF4-FFF2-40B4-BE49-F238E27FC236}">
-                <a16:creationId xmlns:a16="http://schemas.microsoft.com/office/drawing/2014/main" id="{B8D86B4B-9083-7143-BCF3-5EDCF81A9773}"/>
-              </a:ext>
-            </a:extLst>
-          </p:cNvPr>
-          <p:cNvSpPr/>
-          <p:nvPr/>
-        </p:nvSpPr>
-        <p:spPr>
-          <a:xfrm>
-            <a:off x="4928721" y="3010905"/>
-            <a:ext cx="1411170" cy="331393"/>
-          </a:xfrm>
-          <a:prstGeom prst="rect">
-            <a:avLst/>
-          </a:prstGeom>
-          <a:solidFill>
-            <a:schemeClr val="bg1"/>
-          </a:solidFill>
-          <a:ln>
-            <a:solidFill>
-              <a:schemeClr val="bg1"/>
-            </a:solidFill>
-          </a:ln>
-        </p:spPr>
-        <p:style>
-          <a:lnRef idx="2">
-            <a:schemeClr val="accent1">
-              <a:shade val="50000"/>
-            </a:schemeClr>
-          </a:lnRef>
-          <a:fillRef idx="1">
-            <a:schemeClr val="accent1"/>
-          </a:fillRef>
-          <a:effectRef idx="0">
-            <a:schemeClr val="accent1"/>
-          </a:effectRef>
-          <a:fontRef idx="minor">
-            <a:schemeClr val="lt1"/>
-          </a:fontRef>
-        </p:style>
-        <p:txBody>
-          <a:bodyPr rtlCol="0" anchor="ctr"/>
-          <a:lstStyle/>
-          <a:p>
-            <a:pPr algn="ctr"/>
-            <a:r>
-              <a:rPr lang="en-US" dirty="0">
-                <a:solidFill>
-                  <a:srgbClr val="C00000"/>
-                </a:solidFill>
-              </a:rPr>
-              <a:t>Disadvantages</a:t>
-            </a:r>
-            <a:endParaRPr lang="en-RU" dirty="0">
-              <a:solidFill>
-                <a:srgbClr val="C00000"/>
-              </a:solidFill>
-            </a:endParaRPr>
-          </a:p>
-        </p:txBody>
-      </p:sp>
-    </p:spTree>
-    <p:extLst>
-      <p:ext uri="{BB962C8B-B14F-4D97-AF65-F5344CB8AC3E}">
-        <p14:creationId xmlns:p14="http://schemas.microsoft.com/office/powerpoint/2010/main" val="680825618"/>
-      </p:ext>
-    </p:extLst>
-  </p:cSld>
-  <p:clrMapOvr>
-    <a:masterClrMapping/>
-  </p:clrMapOvr>
-</p:sld>
-</file>
-
-<file path=ppt/slides/slide27.xml><?xml version="1.0" encoding="utf-8"?>
+<file path=ppt/slides/slide25.xml><?xml version="1.0" encoding="utf-8"?>
 <p:sld xmlns:a="http://schemas.openxmlformats.org/drawingml/2006/main" xmlns:r="http://schemas.openxmlformats.org/officeDocument/2006/relationships" xmlns:p="http://schemas.openxmlformats.org/presentationml/2006/main">
   <p:cSld>
     <p:spTree>
@@ -32816,7 +32090,7 @@
 </p:sld>
 </file>
 
-<file path=ppt/slides/slide28.xml><?xml version="1.0" encoding="utf-8"?>
+<file path=ppt/slides/slide26.xml><?xml version="1.0" encoding="utf-8"?>
 <p:sld xmlns:a="http://schemas.openxmlformats.org/drawingml/2006/main" xmlns:r="http://schemas.openxmlformats.org/officeDocument/2006/relationships" xmlns:p="http://schemas.openxmlformats.org/presentationml/2006/main">
   <p:cSld>
     <p:spTree>
@@ -33989,7 +33263,7 @@
 </p:sld>
 </file>
 
-<file path=ppt/slides/slide29.xml><?xml version="1.0" encoding="utf-8"?>
+<file path=ppt/slides/slide27.xml><?xml version="1.0" encoding="utf-8"?>
 <p:sld xmlns:a="http://schemas.openxmlformats.org/drawingml/2006/main" xmlns:r="http://schemas.openxmlformats.org/officeDocument/2006/relationships" xmlns:p="http://schemas.openxmlformats.org/presentationml/2006/main">
   <p:cSld>
     <p:spTree>
@@ -36468,1198 +35742,7 @@
 </p:sld>
 </file>
 
-<file path=ppt/slides/slide3.xml><?xml version="1.0" encoding="utf-8"?>
-<p:sld xmlns:a="http://schemas.openxmlformats.org/drawingml/2006/main" xmlns:r="http://schemas.openxmlformats.org/officeDocument/2006/relationships" xmlns:p="http://schemas.openxmlformats.org/presentationml/2006/main">
-  <p:cSld>
-    <p:spTree>
-      <p:nvGrpSpPr>
-        <p:cNvPr id="1" name="Shape 213"/>
-        <p:cNvGrpSpPr/>
-        <p:nvPr/>
-      </p:nvGrpSpPr>
-      <p:grpSpPr>
-        <a:xfrm>
-          <a:off x="0" y="0"/>
-          <a:ext cx="0" cy="0"/>
-          <a:chOff x="0" y="0"/>
-          <a:chExt cx="0" cy="0"/>
-        </a:xfrm>
-      </p:grpSpPr>
-      <p:sp>
-        <p:nvSpPr>
-          <p:cNvPr id="214" name="Google Shape;214;p49"/>
-          <p:cNvSpPr txBox="1">
-            <a:spLocks noGrp="1"/>
-          </p:cNvSpPr>
-          <p:nvPr>
-            <p:ph type="title"/>
-          </p:nvPr>
-        </p:nvSpPr>
-        <p:spPr>
-          <a:xfrm>
-            <a:off x="500550" y="330724"/>
-            <a:ext cx="8520600" cy="1095900"/>
-          </a:xfrm>
-          <a:prstGeom prst="rect">
-            <a:avLst/>
-          </a:prstGeom>
-        </p:spPr>
-        <p:txBody>
-          <a:bodyPr spcFirstLastPara="1" wrap="square" lIns="91425" tIns="91425" rIns="91425" bIns="91425" anchor="t" anchorCtr="0">
-            <a:noAutofit/>
-          </a:bodyPr>
-          <a:lstStyle/>
-          <a:p>
-            <a:pPr marL="0" lvl="0" indent="0" algn="l" rtl="0">
-              <a:spcBef>
-                <a:spcPts val="0"/>
-              </a:spcBef>
-              <a:spcAft>
-                <a:spcPts val="0"/>
-              </a:spcAft>
-              <a:buNone/>
-            </a:pPr>
-            <a:r>
-              <a:rPr lang="ru" sz="3200" b="1"/>
-              <a:t>Правила вебинара</a:t>
-            </a:r>
-            <a:endParaRPr sz="3200" b="1"/>
-          </a:p>
-        </p:txBody>
-      </p:sp>
-      <p:pic>
-        <p:nvPicPr>
-          <p:cNvPr id="215" name="Google Shape;215;p49"/>
-          <p:cNvPicPr preferRelativeResize="0"/>
-          <p:nvPr/>
-        </p:nvPicPr>
-        <p:blipFill rotWithShape="1">
-          <a:blip r:embed="rId3">
-            <a:alphaModFix/>
-          </a:blip>
-          <a:srcRect/>
-          <a:stretch/>
-        </p:blipFill>
-        <p:spPr>
-          <a:xfrm>
-            <a:off x="837650" y="3951281"/>
-            <a:ext cx="692621" cy="692620"/>
-          </a:xfrm>
-          <a:prstGeom prst="rect">
-            <a:avLst/>
-          </a:prstGeom>
-          <a:noFill/>
-          <a:ln>
-            <a:noFill/>
-          </a:ln>
-        </p:spPr>
-      </p:pic>
-      <p:pic>
-        <p:nvPicPr>
-          <p:cNvPr id="216" name="Google Shape;216;p49"/>
-          <p:cNvPicPr preferRelativeResize="0"/>
-          <p:nvPr/>
-        </p:nvPicPr>
-        <p:blipFill rotWithShape="1">
-          <a:blip r:embed="rId4">
-            <a:alphaModFix/>
-          </a:blip>
-          <a:srcRect/>
-          <a:stretch/>
-        </p:blipFill>
-        <p:spPr>
-          <a:xfrm>
-            <a:off x="837650" y="1281613"/>
-            <a:ext cx="692621" cy="692620"/>
-          </a:xfrm>
-          <a:prstGeom prst="rect">
-            <a:avLst/>
-          </a:prstGeom>
-          <a:noFill/>
-          <a:ln>
-            <a:noFill/>
-          </a:ln>
-        </p:spPr>
-      </p:pic>
-      <p:pic>
-        <p:nvPicPr>
-          <p:cNvPr id="217" name="Google Shape;217;p49"/>
-          <p:cNvPicPr preferRelativeResize="0"/>
-          <p:nvPr/>
-        </p:nvPicPr>
-        <p:blipFill rotWithShape="1">
-          <a:blip r:embed="rId5">
-            <a:alphaModFix/>
-          </a:blip>
-          <a:srcRect/>
-          <a:stretch/>
-        </p:blipFill>
-        <p:spPr>
-          <a:xfrm>
-            <a:off x="837651" y="3061406"/>
-            <a:ext cx="692621" cy="692599"/>
-          </a:xfrm>
-          <a:prstGeom prst="rect">
-            <a:avLst/>
-          </a:prstGeom>
-          <a:noFill/>
-          <a:ln>
-            <a:noFill/>
-          </a:ln>
-        </p:spPr>
-      </p:pic>
-      <p:sp>
-        <p:nvSpPr>
-          <p:cNvPr id="218" name="Google Shape;218;p49"/>
-          <p:cNvSpPr txBox="1"/>
-          <p:nvPr/>
-        </p:nvSpPr>
-        <p:spPr>
-          <a:xfrm>
-            <a:off x="1654525" y="1252250"/>
-            <a:ext cx="2475300" cy="646500"/>
-          </a:xfrm>
-          <a:prstGeom prst="rect">
-            <a:avLst/>
-          </a:prstGeom>
-          <a:noFill/>
-          <a:ln>
-            <a:noFill/>
-          </a:ln>
-        </p:spPr>
-        <p:txBody>
-          <a:bodyPr spcFirstLastPara="1" wrap="square" lIns="91425" tIns="91425" rIns="91425" bIns="91425" anchor="t" anchorCtr="0">
-            <a:spAutoFit/>
-          </a:bodyPr>
-          <a:lstStyle/>
-          <a:p>
-            <a:pPr marL="0" lvl="0" indent="0" algn="l" rtl="0">
-              <a:spcBef>
-                <a:spcPts val="0"/>
-              </a:spcBef>
-              <a:spcAft>
-                <a:spcPts val="0"/>
-              </a:spcAft>
-              <a:buNone/>
-            </a:pPr>
-            <a:r>
-              <a:rPr lang="ru" sz="1500">
-                <a:latin typeface="Roboto"/>
-                <a:ea typeface="Roboto"/>
-                <a:cs typeface="Roboto"/>
-                <a:sym typeface="Roboto"/>
-              </a:rPr>
-              <a:t>Активно</a:t>
-            </a:r>
-            <a:endParaRPr sz="1500">
-              <a:latin typeface="Roboto"/>
-              <a:ea typeface="Roboto"/>
-              <a:cs typeface="Roboto"/>
-              <a:sym typeface="Roboto"/>
-            </a:endParaRPr>
-          </a:p>
-          <a:p>
-            <a:pPr marL="0" lvl="0" indent="0" algn="l" rtl="0">
-              <a:spcBef>
-                <a:spcPts val="0"/>
-              </a:spcBef>
-              <a:spcAft>
-                <a:spcPts val="0"/>
-              </a:spcAft>
-              <a:buNone/>
-            </a:pPr>
-            <a:r>
-              <a:rPr lang="ru" sz="1500">
-                <a:latin typeface="Roboto"/>
-                <a:ea typeface="Roboto"/>
-                <a:cs typeface="Roboto"/>
-                <a:sym typeface="Roboto"/>
-              </a:rPr>
-              <a:t>участвуем</a:t>
-            </a:r>
-            <a:endParaRPr sz="1500">
-              <a:latin typeface="Roboto"/>
-              <a:ea typeface="Roboto"/>
-              <a:cs typeface="Roboto"/>
-              <a:sym typeface="Roboto"/>
-            </a:endParaRPr>
-          </a:p>
-        </p:txBody>
-      </p:sp>
-      <p:sp>
-        <p:nvSpPr>
-          <p:cNvPr id="219" name="Google Shape;219;p49"/>
-          <p:cNvSpPr txBox="1"/>
-          <p:nvPr/>
-        </p:nvSpPr>
-        <p:spPr>
-          <a:xfrm>
-            <a:off x="1654525" y="3066419"/>
-            <a:ext cx="3231000" cy="646500"/>
-          </a:xfrm>
-          <a:prstGeom prst="rect">
-            <a:avLst/>
-          </a:prstGeom>
-          <a:noFill/>
-          <a:ln>
-            <a:noFill/>
-          </a:ln>
-        </p:spPr>
-        <p:txBody>
-          <a:bodyPr spcFirstLastPara="1" wrap="square" lIns="91425" tIns="91425" rIns="91425" bIns="91425" anchor="t" anchorCtr="0">
-            <a:spAutoFit/>
-          </a:bodyPr>
-          <a:lstStyle/>
-          <a:p>
-            <a:pPr marL="0" lvl="0" indent="0" algn="l" rtl="0">
-              <a:spcBef>
-                <a:spcPts val="0"/>
-              </a:spcBef>
-              <a:spcAft>
-                <a:spcPts val="0"/>
-              </a:spcAft>
-              <a:buNone/>
-            </a:pPr>
-            <a:r>
-              <a:rPr lang="ru" sz="1500" dirty="0">
-                <a:latin typeface="Roboto"/>
-                <a:ea typeface="Roboto"/>
-                <a:cs typeface="Roboto"/>
-                <a:sym typeface="Roboto"/>
-              </a:rPr>
-              <a:t>Задаем вопрос</a:t>
-            </a:r>
-            <a:endParaRPr sz="1500" dirty="0">
-              <a:latin typeface="Roboto"/>
-              <a:ea typeface="Roboto"/>
-              <a:cs typeface="Roboto"/>
-              <a:sym typeface="Roboto"/>
-            </a:endParaRPr>
-          </a:p>
-          <a:p>
-            <a:pPr marL="0" lvl="0" indent="0" algn="l" rtl="0">
-              <a:spcBef>
-                <a:spcPts val="0"/>
-              </a:spcBef>
-              <a:spcAft>
-                <a:spcPts val="0"/>
-              </a:spcAft>
-              <a:buNone/>
-            </a:pPr>
-            <a:r>
-              <a:rPr lang="ru" sz="1500" dirty="0">
-                <a:latin typeface="Roboto"/>
-                <a:ea typeface="Roboto"/>
-                <a:cs typeface="Roboto"/>
-                <a:sym typeface="Roboto"/>
-              </a:rPr>
-              <a:t>в чат</a:t>
-            </a:r>
-            <a:endParaRPr sz="1500" dirty="0">
-              <a:latin typeface="Roboto"/>
-              <a:ea typeface="Roboto"/>
-              <a:cs typeface="Roboto"/>
-              <a:sym typeface="Roboto"/>
-            </a:endParaRPr>
-          </a:p>
-        </p:txBody>
-      </p:sp>
-      <p:sp>
-        <p:nvSpPr>
-          <p:cNvPr id="220" name="Google Shape;220;p49"/>
-          <p:cNvSpPr txBox="1"/>
-          <p:nvPr/>
-        </p:nvSpPr>
-        <p:spPr>
-          <a:xfrm>
-            <a:off x="1654525" y="3975059"/>
-            <a:ext cx="3231000" cy="646500"/>
-          </a:xfrm>
-          <a:prstGeom prst="rect">
-            <a:avLst/>
-          </a:prstGeom>
-          <a:noFill/>
-          <a:ln>
-            <a:noFill/>
-          </a:ln>
-        </p:spPr>
-        <p:txBody>
-          <a:bodyPr spcFirstLastPara="1" wrap="square" lIns="91425" tIns="91425" rIns="91425" bIns="91425" anchor="t" anchorCtr="0">
-            <a:spAutoFit/>
-          </a:bodyPr>
-          <a:lstStyle/>
-          <a:p>
-            <a:pPr marL="0" lvl="0" indent="0" algn="l" rtl="0">
-              <a:spcBef>
-                <a:spcPts val="0"/>
-              </a:spcBef>
-              <a:spcAft>
-                <a:spcPts val="0"/>
-              </a:spcAft>
-              <a:buNone/>
-            </a:pPr>
-            <a:r>
-              <a:rPr lang="ru" sz="1500">
-                <a:latin typeface="Roboto"/>
-                <a:ea typeface="Roboto"/>
-                <a:cs typeface="Roboto"/>
-                <a:sym typeface="Roboto"/>
-              </a:rPr>
-              <a:t>Вопросы вижу в чате,</a:t>
-            </a:r>
-            <a:endParaRPr sz="1500">
-              <a:latin typeface="Roboto"/>
-              <a:ea typeface="Roboto"/>
-              <a:cs typeface="Roboto"/>
-              <a:sym typeface="Roboto"/>
-            </a:endParaRPr>
-          </a:p>
-          <a:p>
-            <a:pPr marL="0" lvl="0" indent="0" algn="l" rtl="0">
-              <a:spcBef>
-                <a:spcPts val="0"/>
-              </a:spcBef>
-              <a:spcAft>
-                <a:spcPts val="0"/>
-              </a:spcAft>
-              <a:buNone/>
-            </a:pPr>
-            <a:r>
-              <a:rPr lang="ru" sz="1500">
-                <a:latin typeface="Roboto"/>
-                <a:ea typeface="Roboto"/>
-                <a:cs typeface="Roboto"/>
-                <a:sym typeface="Roboto"/>
-              </a:rPr>
-              <a:t>могу ответить не сразу</a:t>
-            </a:r>
-            <a:endParaRPr sz="1500">
-              <a:latin typeface="Roboto"/>
-              <a:ea typeface="Roboto"/>
-              <a:cs typeface="Roboto"/>
-              <a:sym typeface="Roboto"/>
-            </a:endParaRPr>
-          </a:p>
-        </p:txBody>
-      </p:sp>
-      <p:sp>
-        <p:nvSpPr>
-          <p:cNvPr id="221" name="Google Shape;221;p49"/>
-          <p:cNvSpPr txBox="1"/>
-          <p:nvPr/>
-        </p:nvSpPr>
-        <p:spPr>
-          <a:xfrm>
-            <a:off x="1654525" y="2049300"/>
-            <a:ext cx="2475300" cy="646300"/>
-          </a:xfrm>
-          <a:prstGeom prst="rect">
-            <a:avLst/>
-          </a:prstGeom>
-          <a:noFill/>
-          <a:ln>
-            <a:noFill/>
-          </a:ln>
-        </p:spPr>
-        <p:txBody>
-          <a:bodyPr spcFirstLastPara="1" wrap="square" lIns="91425" tIns="91425" rIns="91425" bIns="91425" anchor="t" anchorCtr="0">
-            <a:spAutoFit/>
-          </a:bodyPr>
-          <a:lstStyle/>
-          <a:p>
-            <a:pPr marL="0" lvl="0" indent="0" algn="l" rtl="0">
-              <a:spcBef>
-                <a:spcPts val="0"/>
-              </a:spcBef>
-              <a:spcAft>
-                <a:spcPts val="0"/>
-              </a:spcAft>
-              <a:buNone/>
-            </a:pPr>
-            <a:r>
-              <a:rPr lang="ru" sz="1500" dirty="0">
-                <a:latin typeface="Roboto"/>
-                <a:ea typeface="Roboto"/>
-                <a:cs typeface="Roboto"/>
-                <a:sym typeface="Roboto"/>
-              </a:rPr>
-              <a:t>Off-topic обсуждаем</a:t>
-            </a:r>
-            <a:endParaRPr sz="1500" dirty="0">
-              <a:latin typeface="Roboto"/>
-              <a:ea typeface="Roboto"/>
-              <a:cs typeface="Roboto"/>
-              <a:sym typeface="Roboto"/>
-            </a:endParaRPr>
-          </a:p>
-          <a:p>
-            <a:pPr marL="0" lvl="0" indent="0" algn="l" rtl="0">
-              <a:spcBef>
-                <a:spcPts val="0"/>
-              </a:spcBef>
-              <a:spcAft>
-                <a:spcPts val="0"/>
-              </a:spcAft>
-              <a:buNone/>
-            </a:pPr>
-            <a:r>
-              <a:rPr lang="ru" sz="1500" dirty="0">
-                <a:latin typeface="Roboto"/>
-                <a:ea typeface="Roboto"/>
-                <a:cs typeface="Roboto"/>
-                <a:sym typeface="Roboto"/>
-              </a:rPr>
-              <a:t>в учебной группе </a:t>
-            </a:r>
-            <a:endParaRPr sz="1500" dirty="0">
-              <a:latin typeface="Roboto"/>
-              <a:ea typeface="Roboto"/>
-              <a:cs typeface="Roboto"/>
-              <a:sym typeface="Roboto"/>
-            </a:endParaRPr>
-          </a:p>
-        </p:txBody>
-      </p:sp>
-      <p:sp>
-        <p:nvSpPr>
-          <p:cNvPr id="222" name="Google Shape;222;p49"/>
-          <p:cNvSpPr/>
-          <p:nvPr/>
-        </p:nvSpPr>
-        <p:spPr>
-          <a:xfrm>
-            <a:off x="6046275" y="-8050"/>
-            <a:ext cx="3097500" cy="5143500"/>
-          </a:xfrm>
-          <a:prstGeom prst="rect">
-            <a:avLst/>
-          </a:prstGeom>
-          <a:solidFill>
-            <a:srgbClr val="212121"/>
-          </a:solidFill>
-          <a:ln>
-            <a:noFill/>
-          </a:ln>
-        </p:spPr>
-        <p:txBody>
-          <a:bodyPr spcFirstLastPara="1" wrap="square" lIns="91425" tIns="91425" rIns="91425" bIns="91425" anchor="ctr" anchorCtr="0">
-            <a:noAutofit/>
-          </a:bodyPr>
-          <a:lstStyle/>
-          <a:p>
-            <a:pPr marL="0" lvl="0" indent="0" algn="l" rtl="0">
-              <a:spcBef>
-                <a:spcPts val="0"/>
-              </a:spcBef>
-              <a:spcAft>
-                <a:spcPts val="0"/>
-              </a:spcAft>
-              <a:buNone/>
-            </a:pPr>
-            <a:endParaRPr/>
-          </a:p>
-        </p:txBody>
-      </p:sp>
-      <p:sp>
-        <p:nvSpPr>
-          <p:cNvPr id="223" name="Google Shape;223;p49"/>
-          <p:cNvSpPr txBox="1"/>
-          <p:nvPr/>
-        </p:nvSpPr>
-        <p:spPr>
-          <a:xfrm>
-            <a:off x="6344063" y="1052963"/>
-            <a:ext cx="2044200" cy="800400"/>
-          </a:xfrm>
-          <a:prstGeom prst="rect">
-            <a:avLst/>
-          </a:prstGeom>
-          <a:noFill/>
-          <a:ln>
-            <a:noFill/>
-          </a:ln>
-        </p:spPr>
-        <p:txBody>
-          <a:bodyPr spcFirstLastPara="1" wrap="square" lIns="91425" tIns="91425" rIns="91425" bIns="91425" anchor="t" anchorCtr="0">
-            <a:spAutoFit/>
-          </a:bodyPr>
-          <a:lstStyle/>
-          <a:p>
-            <a:pPr marL="0" lvl="0" indent="0" algn="l" rtl="0">
-              <a:spcBef>
-                <a:spcPts val="0"/>
-              </a:spcBef>
-              <a:spcAft>
-                <a:spcPts val="0"/>
-              </a:spcAft>
-              <a:buNone/>
-            </a:pPr>
-            <a:r>
-              <a:rPr lang="ru" sz="2000" b="1">
-                <a:solidFill>
-                  <a:schemeClr val="lt1"/>
-                </a:solidFill>
-                <a:latin typeface="Roboto"/>
-                <a:ea typeface="Roboto"/>
-                <a:cs typeface="Roboto"/>
-                <a:sym typeface="Roboto"/>
-              </a:rPr>
-              <a:t>Условные </a:t>
-            </a:r>
-            <a:endParaRPr sz="2000" b="1">
-              <a:solidFill>
-                <a:schemeClr val="lt1"/>
-              </a:solidFill>
-              <a:latin typeface="Roboto"/>
-              <a:ea typeface="Roboto"/>
-              <a:cs typeface="Roboto"/>
-              <a:sym typeface="Roboto"/>
-            </a:endParaRPr>
-          </a:p>
-          <a:p>
-            <a:pPr marL="0" lvl="0" indent="0" algn="l" rtl="0">
-              <a:spcBef>
-                <a:spcPts val="0"/>
-              </a:spcBef>
-              <a:spcAft>
-                <a:spcPts val="0"/>
-              </a:spcAft>
-              <a:buNone/>
-            </a:pPr>
-            <a:r>
-              <a:rPr lang="ru" sz="2000" b="1">
-                <a:solidFill>
-                  <a:schemeClr val="lt1"/>
-                </a:solidFill>
-                <a:latin typeface="Roboto"/>
-                <a:ea typeface="Roboto"/>
-                <a:cs typeface="Roboto"/>
-                <a:sym typeface="Roboto"/>
-              </a:rPr>
-              <a:t>обозначения</a:t>
-            </a:r>
-            <a:endParaRPr sz="2000" b="1">
-              <a:solidFill>
-                <a:schemeClr val="lt1"/>
-              </a:solidFill>
-              <a:latin typeface="Roboto"/>
-              <a:ea typeface="Roboto"/>
-              <a:cs typeface="Roboto"/>
-              <a:sym typeface="Roboto"/>
-            </a:endParaRPr>
-          </a:p>
-        </p:txBody>
-      </p:sp>
-      <p:pic>
-        <p:nvPicPr>
-          <p:cNvPr id="224" name="Google Shape;224;p49"/>
-          <p:cNvPicPr preferRelativeResize="0"/>
-          <p:nvPr/>
-        </p:nvPicPr>
-        <p:blipFill rotWithShape="1">
-          <a:blip r:embed="rId6">
-            <a:alphaModFix/>
-          </a:blip>
-          <a:srcRect/>
-          <a:stretch/>
-        </p:blipFill>
-        <p:spPr>
-          <a:xfrm>
-            <a:off x="6438593" y="1912032"/>
-            <a:ext cx="330301" cy="330303"/>
-          </a:xfrm>
-          <a:prstGeom prst="rect">
-            <a:avLst/>
-          </a:prstGeom>
-          <a:noFill/>
-          <a:ln>
-            <a:noFill/>
-          </a:ln>
-        </p:spPr>
-      </p:pic>
-      <p:sp>
-        <p:nvSpPr>
-          <p:cNvPr id="225" name="Google Shape;225;p49"/>
-          <p:cNvSpPr txBox="1"/>
-          <p:nvPr/>
-        </p:nvSpPr>
-        <p:spPr>
-          <a:xfrm>
-            <a:off x="6829363" y="1898744"/>
-            <a:ext cx="2044200" cy="354000"/>
-          </a:xfrm>
-          <a:prstGeom prst="rect">
-            <a:avLst/>
-          </a:prstGeom>
-          <a:noFill/>
-          <a:ln>
-            <a:noFill/>
-          </a:ln>
-        </p:spPr>
-        <p:txBody>
-          <a:bodyPr spcFirstLastPara="1" wrap="square" lIns="91425" tIns="91425" rIns="91425" bIns="91425" anchor="t" anchorCtr="0">
-            <a:spAutoFit/>
-          </a:bodyPr>
-          <a:lstStyle/>
-          <a:p>
-            <a:pPr marL="0" lvl="0" indent="0" algn="l" rtl="0">
-              <a:spcBef>
-                <a:spcPts val="0"/>
-              </a:spcBef>
-              <a:spcAft>
-                <a:spcPts val="0"/>
-              </a:spcAft>
-              <a:buNone/>
-            </a:pPr>
-            <a:r>
-              <a:rPr lang="ru" sz="1100">
-                <a:solidFill>
-                  <a:schemeClr val="lt1"/>
-                </a:solidFill>
-                <a:latin typeface="Roboto"/>
-                <a:ea typeface="Roboto"/>
-                <a:cs typeface="Roboto"/>
-                <a:sym typeface="Roboto"/>
-              </a:rPr>
-              <a:t>Индивидуально</a:t>
-            </a:r>
-            <a:endParaRPr sz="1100">
-              <a:solidFill>
-                <a:schemeClr val="lt1"/>
-              </a:solidFill>
-              <a:latin typeface="Roboto"/>
-              <a:ea typeface="Roboto"/>
-              <a:cs typeface="Roboto"/>
-              <a:sym typeface="Roboto"/>
-            </a:endParaRPr>
-          </a:p>
-        </p:txBody>
-      </p:sp>
-      <p:pic>
-        <p:nvPicPr>
-          <p:cNvPr id="226" name="Google Shape;226;p49"/>
-          <p:cNvPicPr preferRelativeResize="0"/>
-          <p:nvPr/>
-        </p:nvPicPr>
-        <p:blipFill rotWithShape="1">
-          <a:blip r:embed="rId7">
-            <a:alphaModFix/>
-          </a:blip>
-          <a:srcRect/>
-          <a:stretch/>
-        </p:blipFill>
-        <p:spPr>
-          <a:xfrm>
-            <a:off x="6438593" y="2392126"/>
-            <a:ext cx="330301" cy="330303"/>
-          </a:xfrm>
-          <a:prstGeom prst="rect">
-            <a:avLst/>
-          </a:prstGeom>
-          <a:noFill/>
-          <a:ln>
-            <a:noFill/>
-          </a:ln>
-        </p:spPr>
-      </p:pic>
-      <p:sp>
-        <p:nvSpPr>
-          <p:cNvPr id="227" name="Google Shape;227;p49"/>
-          <p:cNvSpPr txBox="1"/>
-          <p:nvPr/>
-        </p:nvSpPr>
-        <p:spPr>
-          <a:xfrm>
-            <a:off x="6829363" y="2291099"/>
-            <a:ext cx="2044200" cy="523200"/>
-          </a:xfrm>
-          <a:prstGeom prst="rect">
-            <a:avLst/>
-          </a:prstGeom>
-          <a:noFill/>
-          <a:ln>
-            <a:noFill/>
-          </a:ln>
-        </p:spPr>
-        <p:txBody>
-          <a:bodyPr spcFirstLastPara="1" wrap="square" lIns="91425" tIns="91425" rIns="91425" bIns="91425" anchor="t" anchorCtr="0">
-            <a:spAutoFit/>
-          </a:bodyPr>
-          <a:lstStyle/>
-          <a:p>
-            <a:pPr marL="0" lvl="0" indent="0" algn="l" rtl="0">
-              <a:spcBef>
-                <a:spcPts val="0"/>
-              </a:spcBef>
-              <a:spcAft>
-                <a:spcPts val="0"/>
-              </a:spcAft>
-              <a:buNone/>
-            </a:pPr>
-            <a:r>
-              <a:rPr lang="ru" sz="1100">
-                <a:solidFill>
-                  <a:schemeClr val="lt1"/>
-                </a:solidFill>
-                <a:latin typeface="Roboto"/>
-                <a:ea typeface="Roboto"/>
-                <a:cs typeface="Roboto"/>
-                <a:sym typeface="Roboto"/>
-              </a:rPr>
-              <a:t>Время, необходимое</a:t>
-            </a:r>
-            <a:endParaRPr sz="1100">
-              <a:solidFill>
-                <a:schemeClr val="lt1"/>
-              </a:solidFill>
-              <a:latin typeface="Roboto"/>
-              <a:ea typeface="Roboto"/>
-              <a:cs typeface="Roboto"/>
-              <a:sym typeface="Roboto"/>
-            </a:endParaRPr>
-          </a:p>
-          <a:p>
-            <a:pPr marL="0" lvl="0" indent="0" algn="l" rtl="0">
-              <a:spcBef>
-                <a:spcPts val="0"/>
-              </a:spcBef>
-              <a:spcAft>
-                <a:spcPts val="0"/>
-              </a:spcAft>
-              <a:buNone/>
-            </a:pPr>
-            <a:r>
-              <a:rPr lang="ru" sz="1100">
-                <a:solidFill>
-                  <a:schemeClr val="lt1"/>
-                </a:solidFill>
-                <a:latin typeface="Roboto"/>
-                <a:ea typeface="Roboto"/>
-                <a:cs typeface="Roboto"/>
-                <a:sym typeface="Roboto"/>
-              </a:rPr>
-              <a:t>на активность</a:t>
-            </a:r>
-            <a:endParaRPr sz="1100">
-              <a:solidFill>
-                <a:schemeClr val="lt1"/>
-              </a:solidFill>
-              <a:latin typeface="Roboto"/>
-              <a:ea typeface="Roboto"/>
-              <a:cs typeface="Roboto"/>
-              <a:sym typeface="Roboto"/>
-            </a:endParaRPr>
-          </a:p>
-        </p:txBody>
-      </p:sp>
-      <p:pic>
-        <p:nvPicPr>
-          <p:cNvPr id="228" name="Google Shape;228;p49"/>
-          <p:cNvPicPr preferRelativeResize="0"/>
-          <p:nvPr/>
-        </p:nvPicPr>
-        <p:blipFill rotWithShape="1">
-          <a:blip r:embed="rId8">
-            <a:alphaModFix/>
-          </a:blip>
-          <a:srcRect/>
-          <a:stretch/>
-        </p:blipFill>
-        <p:spPr>
-          <a:xfrm>
-            <a:off x="6438593" y="2872220"/>
-            <a:ext cx="330301" cy="330303"/>
-          </a:xfrm>
-          <a:prstGeom prst="rect">
-            <a:avLst/>
-          </a:prstGeom>
-          <a:noFill/>
-          <a:ln>
-            <a:noFill/>
-          </a:ln>
-        </p:spPr>
-      </p:pic>
-      <p:sp>
-        <p:nvSpPr>
-          <p:cNvPr id="229" name="Google Shape;229;p49"/>
-          <p:cNvSpPr txBox="1"/>
-          <p:nvPr/>
-        </p:nvSpPr>
-        <p:spPr>
-          <a:xfrm>
-            <a:off x="6829363" y="2873300"/>
-            <a:ext cx="2044200" cy="354000"/>
-          </a:xfrm>
-          <a:prstGeom prst="rect">
-            <a:avLst/>
-          </a:prstGeom>
-          <a:noFill/>
-          <a:ln>
-            <a:noFill/>
-          </a:ln>
-        </p:spPr>
-        <p:txBody>
-          <a:bodyPr spcFirstLastPara="1" wrap="square" lIns="91425" tIns="91425" rIns="91425" bIns="91425" anchor="t" anchorCtr="0">
-            <a:spAutoFit/>
-          </a:bodyPr>
-          <a:lstStyle/>
-          <a:p>
-            <a:pPr marL="0" lvl="0" indent="0" algn="l" rtl="0">
-              <a:spcBef>
-                <a:spcPts val="0"/>
-              </a:spcBef>
-              <a:spcAft>
-                <a:spcPts val="0"/>
-              </a:spcAft>
-              <a:buNone/>
-            </a:pPr>
-            <a:r>
-              <a:rPr lang="ru" sz="1100">
-                <a:solidFill>
-                  <a:schemeClr val="lt1"/>
-                </a:solidFill>
-                <a:latin typeface="Roboto"/>
-                <a:ea typeface="Roboto"/>
-                <a:cs typeface="Roboto"/>
-                <a:sym typeface="Roboto"/>
-              </a:rPr>
-              <a:t>Пишем в чат</a:t>
-            </a:r>
-            <a:endParaRPr sz="1100">
-              <a:solidFill>
-                <a:schemeClr val="lt1"/>
-              </a:solidFill>
-              <a:latin typeface="Roboto"/>
-              <a:ea typeface="Roboto"/>
-              <a:cs typeface="Roboto"/>
-              <a:sym typeface="Roboto"/>
-            </a:endParaRPr>
-          </a:p>
-        </p:txBody>
-      </p:sp>
-      <p:pic>
-        <p:nvPicPr>
-          <p:cNvPr id="230" name="Google Shape;230;p49"/>
-          <p:cNvPicPr preferRelativeResize="0"/>
-          <p:nvPr/>
-        </p:nvPicPr>
-        <p:blipFill rotWithShape="1">
-          <a:blip r:embed="rId9">
-            <a:alphaModFix/>
-          </a:blip>
-          <a:srcRect/>
-          <a:stretch/>
-        </p:blipFill>
-        <p:spPr>
-          <a:xfrm>
-            <a:off x="6438593" y="3352314"/>
-            <a:ext cx="330301" cy="330303"/>
-          </a:xfrm>
-          <a:prstGeom prst="rect">
-            <a:avLst/>
-          </a:prstGeom>
-          <a:noFill/>
-          <a:ln>
-            <a:noFill/>
-          </a:ln>
-        </p:spPr>
-      </p:pic>
-      <p:sp>
-        <p:nvSpPr>
-          <p:cNvPr id="231" name="Google Shape;231;p49"/>
-          <p:cNvSpPr txBox="1"/>
-          <p:nvPr/>
-        </p:nvSpPr>
-        <p:spPr>
-          <a:xfrm>
-            <a:off x="6829363" y="3359347"/>
-            <a:ext cx="2044200" cy="354000"/>
-          </a:xfrm>
-          <a:prstGeom prst="rect">
-            <a:avLst/>
-          </a:prstGeom>
-          <a:noFill/>
-          <a:ln>
-            <a:noFill/>
-          </a:ln>
-        </p:spPr>
-        <p:txBody>
-          <a:bodyPr spcFirstLastPara="1" wrap="square" lIns="91425" tIns="91425" rIns="91425" bIns="91425" anchor="t" anchorCtr="0">
-            <a:spAutoFit/>
-          </a:bodyPr>
-          <a:lstStyle/>
-          <a:p>
-            <a:pPr marL="0" lvl="0" indent="0" algn="l" rtl="0">
-              <a:spcBef>
-                <a:spcPts val="0"/>
-              </a:spcBef>
-              <a:spcAft>
-                <a:spcPts val="0"/>
-              </a:spcAft>
-              <a:buNone/>
-            </a:pPr>
-            <a:r>
-              <a:rPr lang="ru" sz="1100">
-                <a:solidFill>
-                  <a:schemeClr val="lt1"/>
-                </a:solidFill>
-                <a:latin typeface="Roboto"/>
-                <a:ea typeface="Roboto"/>
-                <a:cs typeface="Roboto"/>
-                <a:sym typeface="Roboto"/>
-              </a:rPr>
-              <a:t>Говорим голосом</a:t>
-            </a:r>
-            <a:endParaRPr sz="1100">
-              <a:solidFill>
-                <a:schemeClr val="lt1"/>
-              </a:solidFill>
-              <a:latin typeface="Roboto"/>
-              <a:ea typeface="Roboto"/>
-              <a:cs typeface="Roboto"/>
-              <a:sym typeface="Roboto"/>
-            </a:endParaRPr>
-          </a:p>
-        </p:txBody>
-      </p:sp>
-      <p:pic>
-        <p:nvPicPr>
-          <p:cNvPr id="232" name="Google Shape;232;p49"/>
-          <p:cNvPicPr preferRelativeResize="0"/>
-          <p:nvPr/>
-        </p:nvPicPr>
-        <p:blipFill rotWithShape="1">
-          <a:blip r:embed="rId10">
-            <a:alphaModFix/>
-          </a:blip>
-          <a:srcRect/>
-          <a:stretch/>
-        </p:blipFill>
-        <p:spPr>
-          <a:xfrm>
-            <a:off x="6438593" y="3832409"/>
-            <a:ext cx="330301" cy="330301"/>
-          </a:xfrm>
-          <a:prstGeom prst="rect">
-            <a:avLst/>
-          </a:prstGeom>
-          <a:noFill/>
-          <a:ln>
-            <a:noFill/>
-          </a:ln>
-        </p:spPr>
-      </p:pic>
-      <p:sp>
-        <p:nvSpPr>
-          <p:cNvPr id="233" name="Google Shape;233;p49"/>
-          <p:cNvSpPr txBox="1"/>
-          <p:nvPr/>
-        </p:nvSpPr>
-        <p:spPr>
-          <a:xfrm>
-            <a:off x="6829363" y="3827568"/>
-            <a:ext cx="2044200" cy="354000"/>
-          </a:xfrm>
-          <a:prstGeom prst="rect">
-            <a:avLst/>
-          </a:prstGeom>
-          <a:noFill/>
-          <a:ln>
-            <a:noFill/>
-          </a:ln>
-        </p:spPr>
-        <p:txBody>
-          <a:bodyPr spcFirstLastPara="1" wrap="square" lIns="91425" tIns="91425" rIns="91425" bIns="91425" anchor="t" anchorCtr="0">
-            <a:spAutoFit/>
-          </a:bodyPr>
-          <a:lstStyle/>
-          <a:p>
-            <a:pPr marL="0" lvl="0" indent="0" algn="l" rtl="0">
-              <a:spcBef>
-                <a:spcPts val="0"/>
-              </a:spcBef>
-              <a:spcAft>
-                <a:spcPts val="0"/>
-              </a:spcAft>
-              <a:buNone/>
-            </a:pPr>
-            <a:r>
-              <a:rPr lang="ru" sz="1100">
-                <a:solidFill>
-                  <a:schemeClr val="lt1"/>
-                </a:solidFill>
-                <a:latin typeface="Roboto"/>
-                <a:ea typeface="Roboto"/>
-                <a:cs typeface="Roboto"/>
-                <a:sym typeface="Roboto"/>
-              </a:rPr>
-              <a:t>Документ</a:t>
-            </a:r>
-            <a:endParaRPr sz="1100">
-              <a:solidFill>
-                <a:schemeClr val="lt1"/>
-              </a:solidFill>
-              <a:latin typeface="Roboto"/>
-              <a:ea typeface="Roboto"/>
-              <a:cs typeface="Roboto"/>
-              <a:sym typeface="Roboto"/>
-            </a:endParaRPr>
-          </a:p>
-        </p:txBody>
-      </p:sp>
-      <p:pic>
-        <p:nvPicPr>
-          <p:cNvPr id="234" name="Google Shape;234;p49"/>
-          <p:cNvPicPr preferRelativeResize="0"/>
-          <p:nvPr/>
-        </p:nvPicPr>
-        <p:blipFill rotWithShape="1">
-          <a:blip r:embed="rId11">
-            <a:alphaModFix/>
-          </a:blip>
-          <a:srcRect/>
-          <a:stretch/>
-        </p:blipFill>
-        <p:spPr>
-          <a:xfrm>
-            <a:off x="6438593" y="4312503"/>
-            <a:ext cx="330301" cy="330303"/>
-          </a:xfrm>
-          <a:prstGeom prst="rect">
-            <a:avLst/>
-          </a:prstGeom>
-          <a:noFill/>
-          <a:ln>
-            <a:noFill/>
-          </a:ln>
-        </p:spPr>
-      </p:pic>
-      <p:sp>
-        <p:nvSpPr>
-          <p:cNvPr id="235" name="Google Shape;235;p49"/>
-          <p:cNvSpPr txBox="1"/>
-          <p:nvPr/>
-        </p:nvSpPr>
-        <p:spPr>
-          <a:xfrm>
-            <a:off x="6829363" y="4223086"/>
-            <a:ext cx="2044200" cy="523200"/>
-          </a:xfrm>
-          <a:prstGeom prst="rect">
-            <a:avLst/>
-          </a:prstGeom>
-          <a:noFill/>
-          <a:ln>
-            <a:noFill/>
-          </a:ln>
-        </p:spPr>
-        <p:txBody>
-          <a:bodyPr spcFirstLastPara="1" wrap="square" lIns="91425" tIns="91425" rIns="91425" bIns="91425" anchor="t" anchorCtr="0">
-            <a:spAutoFit/>
-          </a:bodyPr>
-          <a:lstStyle/>
-          <a:p>
-            <a:pPr marL="0" lvl="0" indent="0" algn="l" rtl="0">
-              <a:spcBef>
-                <a:spcPts val="0"/>
-              </a:spcBef>
-              <a:spcAft>
-                <a:spcPts val="0"/>
-              </a:spcAft>
-              <a:buNone/>
-            </a:pPr>
-            <a:r>
-              <a:rPr lang="ru" sz="1100">
-                <a:solidFill>
-                  <a:schemeClr val="lt1"/>
-                </a:solidFill>
-                <a:latin typeface="Roboto"/>
-                <a:ea typeface="Roboto"/>
-                <a:cs typeface="Roboto"/>
-                <a:sym typeface="Roboto"/>
-              </a:rPr>
-              <a:t>Ответьте себе или</a:t>
-            </a:r>
-            <a:endParaRPr sz="1100">
-              <a:solidFill>
-                <a:schemeClr val="lt1"/>
-              </a:solidFill>
-              <a:latin typeface="Roboto"/>
-              <a:ea typeface="Roboto"/>
-              <a:cs typeface="Roboto"/>
-              <a:sym typeface="Roboto"/>
-            </a:endParaRPr>
-          </a:p>
-          <a:p>
-            <a:pPr marL="0" lvl="0" indent="0" algn="l" rtl="0">
-              <a:spcBef>
-                <a:spcPts val="0"/>
-              </a:spcBef>
-              <a:spcAft>
-                <a:spcPts val="0"/>
-              </a:spcAft>
-              <a:buNone/>
-            </a:pPr>
-            <a:r>
-              <a:rPr lang="ru" sz="1100">
-                <a:solidFill>
-                  <a:schemeClr val="lt1"/>
-                </a:solidFill>
-                <a:latin typeface="Roboto"/>
-                <a:ea typeface="Roboto"/>
-                <a:cs typeface="Roboto"/>
-                <a:sym typeface="Roboto"/>
-              </a:rPr>
-              <a:t>задайте вопрос</a:t>
-            </a:r>
-            <a:endParaRPr sz="1100">
-              <a:solidFill>
-                <a:schemeClr val="lt1"/>
-              </a:solidFill>
-              <a:latin typeface="Roboto"/>
-              <a:ea typeface="Roboto"/>
-              <a:cs typeface="Roboto"/>
-              <a:sym typeface="Roboto"/>
-            </a:endParaRPr>
-          </a:p>
-        </p:txBody>
-      </p:sp>
-      <p:pic>
-        <p:nvPicPr>
-          <p:cNvPr id="237" name="Google Shape;237;p49"/>
-          <p:cNvPicPr preferRelativeResize="0"/>
-          <p:nvPr/>
-        </p:nvPicPr>
-        <p:blipFill rotWithShape="1">
-          <a:blip r:embed="rId12">
-            <a:alphaModFix/>
-          </a:blip>
-          <a:srcRect/>
-          <a:stretch/>
-        </p:blipFill>
-        <p:spPr>
-          <a:xfrm>
-            <a:off x="837650" y="2171500"/>
-            <a:ext cx="692625" cy="692625"/>
-          </a:xfrm>
-          <a:prstGeom prst="rect">
-            <a:avLst/>
-          </a:prstGeom>
-          <a:noFill/>
-          <a:ln>
-            <a:noFill/>
-          </a:ln>
-        </p:spPr>
-      </p:pic>
-    </p:spTree>
-  </p:cSld>
-  <p:clrMapOvr>
-    <a:masterClrMapping/>
-  </p:clrMapOvr>
-</p:sld>
-</file>
-
-<file path=ppt/slides/slide30.xml><?xml version="1.0" encoding="utf-8"?>
+<file path=ppt/slides/slide28.xml><?xml version="1.0" encoding="utf-8"?>
 <p:sld xmlns:a="http://schemas.openxmlformats.org/drawingml/2006/main" xmlns:r="http://schemas.openxmlformats.org/officeDocument/2006/relationships" xmlns:p="http://schemas.openxmlformats.org/presentationml/2006/main">
   <p:cSld>
     <p:spTree>
@@ -38654,14 +36737,14 @@
             <a:avLst/>
           </a:prstGeom>
           <a:solidFill>
-            <a:schemeClr val="accent1">
-              <a:lumMod val="20000"/>
-              <a:lumOff val="80000"/>
+            <a:schemeClr val="accent4">
+              <a:lumMod val="40000"/>
+              <a:lumOff val="60000"/>
             </a:schemeClr>
           </a:solidFill>
           <a:ln>
             <a:solidFill>
-              <a:schemeClr val="accent1"/>
+              <a:srgbClr val="C00000"/>
             </a:solidFill>
           </a:ln>
         </p:spPr>
@@ -38846,14 +36929,16 @@
             <a:avLst/>
           </a:prstGeom>
           <a:solidFill>
-            <a:schemeClr val="accent1">
-              <a:lumMod val="20000"/>
-              <a:lumOff val="80000"/>
+            <a:schemeClr val="bg1">
+              <a:lumMod val="85000"/>
             </a:schemeClr>
           </a:solidFill>
           <a:ln>
             <a:solidFill>
-              <a:schemeClr val="accent1"/>
+              <a:schemeClr val="bg2">
+                <a:lumMod val="60000"/>
+                <a:lumOff val="40000"/>
+              </a:schemeClr>
             </a:solidFill>
           </a:ln>
         </p:spPr>
@@ -38910,14 +36995,16 @@
             <a:avLst/>
           </a:prstGeom>
           <a:solidFill>
-            <a:schemeClr val="accent1">
-              <a:lumMod val="20000"/>
-              <a:lumOff val="80000"/>
+            <a:schemeClr val="bg1">
+              <a:lumMod val="85000"/>
             </a:schemeClr>
           </a:solidFill>
           <a:ln>
             <a:solidFill>
-              <a:schemeClr val="accent1"/>
+              <a:schemeClr val="bg2">
+                <a:lumMod val="60000"/>
+                <a:lumOff val="40000"/>
+              </a:schemeClr>
             </a:solidFill>
           </a:ln>
         </p:spPr>
@@ -38974,14 +37061,16 @@
             <a:avLst/>
           </a:prstGeom>
           <a:solidFill>
-            <a:schemeClr val="accent1">
-              <a:lumMod val="20000"/>
-              <a:lumOff val="80000"/>
+            <a:schemeClr val="bg1">
+              <a:lumMod val="85000"/>
             </a:schemeClr>
           </a:solidFill>
           <a:ln>
             <a:solidFill>
-              <a:schemeClr val="accent1"/>
+              <a:schemeClr val="bg2">
+                <a:lumMod val="60000"/>
+                <a:lumOff val="40000"/>
+              </a:schemeClr>
             </a:solidFill>
           </a:ln>
         </p:spPr>
@@ -39038,14 +37127,16 @@
             <a:avLst/>
           </a:prstGeom>
           <a:solidFill>
-            <a:schemeClr val="accent1">
-              <a:lumMod val="20000"/>
-              <a:lumOff val="80000"/>
+            <a:schemeClr val="bg1">
+              <a:lumMod val="85000"/>
             </a:schemeClr>
           </a:solidFill>
           <a:ln>
             <a:solidFill>
-              <a:schemeClr val="accent1"/>
+              <a:schemeClr val="bg2">
+                <a:lumMod val="60000"/>
+                <a:lumOff val="40000"/>
+              </a:schemeClr>
             </a:solidFill>
           </a:ln>
         </p:spPr>
@@ -39274,14 +37365,16 @@
             <a:avLst/>
           </a:prstGeom>
           <a:solidFill>
-            <a:schemeClr val="accent1">
-              <a:lumMod val="20000"/>
-              <a:lumOff val="80000"/>
+            <a:schemeClr val="bg1">
+              <a:lumMod val="85000"/>
             </a:schemeClr>
           </a:solidFill>
           <a:ln>
             <a:solidFill>
-              <a:schemeClr val="accent1"/>
+              <a:schemeClr val="bg2">
+                <a:lumMod val="60000"/>
+                <a:lumOff val="40000"/>
+              </a:schemeClr>
             </a:solidFill>
           </a:ln>
         </p:spPr>
@@ -39338,14 +37431,16 @@
             <a:avLst/>
           </a:prstGeom>
           <a:solidFill>
-            <a:schemeClr val="accent1">
-              <a:lumMod val="20000"/>
-              <a:lumOff val="80000"/>
+            <a:schemeClr val="bg1">
+              <a:lumMod val="85000"/>
             </a:schemeClr>
           </a:solidFill>
           <a:ln>
             <a:solidFill>
-              <a:schemeClr val="accent1"/>
+              <a:schemeClr val="bg2">
+                <a:lumMod val="60000"/>
+                <a:lumOff val="40000"/>
+              </a:schemeClr>
             </a:solidFill>
           </a:ln>
         </p:spPr>
@@ -39402,14 +37497,16 @@
             <a:avLst/>
           </a:prstGeom>
           <a:solidFill>
-            <a:schemeClr val="accent1">
-              <a:lumMod val="20000"/>
-              <a:lumOff val="80000"/>
+            <a:schemeClr val="bg1">
+              <a:lumMod val="85000"/>
             </a:schemeClr>
           </a:solidFill>
           <a:ln>
             <a:solidFill>
-              <a:schemeClr val="accent1"/>
+              <a:schemeClr val="bg2">
+                <a:lumMod val="60000"/>
+                <a:lumOff val="40000"/>
+              </a:schemeClr>
             </a:solidFill>
           </a:ln>
         </p:spPr>
@@ -39466,14 +37563,16 @@
             <a:avLst/>
           </a:prstGeom>
           <a:solidFill>
-            <a:schemeClr val="accent1">
-              <a:lumMod val="20000"/>
-              <a:lumOff val="80000"/>
+            <a:schemeClr val="bg1">
+              <a:lumMod val="85000"/>
             </a:schemeClr>
           </a:solidFill>
           <a:ln>
             <a:solidFill>
-              <a:schemeClr val="accent1"/>
+              <a:schemeClr val="bg2">
+                <a:lumMod val="60000"/>
+                <a:lumOff val="40000"/>
+              </a:schemeClr>
             </a:solidFill>
           </a:ln>
         </p:spPr>
@@ -39530,14 +37629,16 @@
             <a:avLst/>
           </a:prstGeom>
           <a:solidFill>
-            <a:schemeClr val="accent1">
-              <a:lumMod val="20000"/>
-              <a:lumOff val="80000"/>
+            <a:schemeClr val="bg1">
+              <a:lumMod val="85000"/>
             </a:schemeClr>
           </a:solidFill>
           <a:ln>
             <a:solidFill>
-              <a:schemeClr val="accent1"/>
+              <a:schemeClr val="bg2">
+                <a:lumMod val="60000"/>
+                <a:lumOff val="40000"/>
+              </a:schemeClr>
             </a:solidFill>
           </a:ln>
         </p:spPr>
@@ -39594,14 +37695,16 @@
             <a:avLst/>
           </a:prstGeom>
           <a:solidFill>
-            <a:schemeClr val="accent1">
-              <a:lumMod val="20000"/>
-              <a:lumOff val="80000"/>
+            <a:schemeClr val="bg1">
+              <a:lumMod val="85000"/>
             </a:schemeClr>
           </a:solidFill>
           <a:ln>
             <a:solidFill>
-              <a:schemeClr val="accent1"/>
+              <a:schemeClr val="bg2">
+                <a:lumMod val="60000"/>
+                <a:lumOff val="40000"/>
+              </a:schemeClr>
             </a:solidFill>
           </a:ln>
         </p:spPr>
@@ -39658,14 +37761,16 @@
             <a:avLst/>
           </a:prstGeom>
           <a:solidFill>
-            <a:schemeClr val="accent1">
-              <a:lumMod val="20000"/>
-              <a:lumOff val="80000"/>
+            <a:schemeClr val="bg1">
+              <a:lumMod val="85000"/>
             </a:schemeClr>
           </a:solidFill>
           <a:ln>
             <a:solidFill>
-              <a:schemeClr val="accent1"/>
+              <a:schemeClr val="bg2">
+                <a:lumMod val="60000"/>
+                <a:lumOff val="40000"/>
+              </a:schemeClr>
             </a:solidFill>
           </a:ln>
         </p:spPr>
@@ -39722,14 +37827,16 @@
             <a:avLst/>
           </a:prstGeom>
           <a:solidFill>
-            <a:schemeClr val="accent1">
-              <a:lumMod val="20000"/>
-              <a:lumOff val="80000"/>
+            <a:schemeClr val="bg1">
+              <a:lumMod val="85000"/>
             </a:schemeClr>
           </a:solidFill>
           <a:ln>
             <a:solidFill>
-              <a:schemeClr val="accent1"/>
+              <a:schemeClr val="bg2">
+                <a:lumMod val="60000"/>
+                <a:lumOff val="40000"/>
+              </a:schemeClr>
             </a:solidFill>
           </a:ln>
         </p:spPr>
@@ -39786,14 +37893,16 @@
             <a:avLst/>
           </a:prstGeom>
           <a:solidFill>
-            <a:schemeClr val="accent1">
-              <a:lumMod val="20000"/>
-              <a:lumOff val="80000"/>
+            <a:schemeClr val="bg1">
+              <a:lumMod val="85000"/>
             </a:schemeClr>
           </a:solidFill>
           <a:ln>
             <a:solidFill>
-              <a:schemeClr val="accent1"/>
+              <a:schemeClr val="bg2">
+                <a:lumMod val="60000"/>
+                <a:lumOff val="40000"/>
+              </a:schemeClr>
             </a:solidFill>
           </a:ln>
         </p:spPr>
@@ -39850,14 +37959,16 @@
             <a:avLst/>
           </a:prstGeom>
           <a:solidFill>
-            <a:schemeClr val="accent1">
-              <a:lumMod val="20000"/>
-              <a:lumOff val="80000"/>
+            <a:schemeClr val="bg1">
+              <a:lumMod val="85000"/>
             </a:schemeClr>
           </a:solidFill>
           <a:ln>
             <a:solidFill>
-              <a:schemeClr val="accent1"/>
+              <a:schemeClr val="bg2">
+                <a:lumMod val="60000"/>
+                <a:lumOff val="40000"/>
+              </a:schemeClr>
             </a:solidFill>
           </a:ln>
         </p:spPr>
@@ -39914,14 +38025,16 @@
             <a:avLst/>
           </a:prstGeom>
           <a:solidFill>
-            <a:schemeClr val="accent1">
-              <a:lumMod val="20000"/>
-              <a:lumOff val="80000"/>
+            <a:schemeClr val="bg1">
+              <a:lumMod val="85000"/>
             </a:schemeClr>
           </a:solidFill>
           <a:ln>
             <a:solidFill>
-              <a:schemeClr val="accent1"/>
+              <a:schemeClr val="bg2">
+                <a:lumMod val="60000"/>
+                <a:lumOff val="40000"/>
+              </a:schemeClr>
             </a:solidFill>
           </a:ln>
         </p:spPr>
@@ -41018,7 +39131,7 @@
 </p:sld>
 </file>
 
-<file path=ppt/slides/slide31.xml><?xml version="1.0" encoding="utf-8"?>
+<file path=ppt/slides/slide29.xml><?xml version="1.0" encoding="utf-8"?>
 <p:sld xmlns:a="http://schemas.openxmlformats.org/drawingml/2006/main" xmlns:r="http://schemas.openxmlformats.org/officeDocument/2006/relationships" xmlns:p="http://schemas.openxmlformats.org/presentationml/2006/main">
   <p:cSld>
     <p:spTree>
@@ -41085,7 +39198,1198 @@
 </p:sld>
 </file>
 
-<file path=ppt/slides/slide32.xml><?xml version="1.0" encoding="utf-8"?>
+<file path=ppt/slides/slide3.xml><?xml version="1.0" encoding="utf-8"?>
+<p:sld xmlns:a="http://schemas.openxmlformats.org/drawingml/2006/main" xmlns:r="http://schemas.openxmlformats.org/officeDocument/2006/relationships" xmlns:p="http://schemas.openxmlformats.org/presentationml/2006/main">
+  <p:cSld>
+    <p:spTree>
+      <p:nvGrpSpPr>
+        <p:cNvPr id="1" name="Shape 213"/>
+        <p:cNvGrpSpPr/>
+        <p:nvPr/>
+      </p:nvGrpSpPr>
+      <p:grpSpPr>
+        <a:xfrm>
+          <a:off x="0" y="0"/>
+          <a:ext cx="0" cy="0"/>
+          <a:chOff x="0" y="0"/>
+          <a:chExt cx="0" cy="0"/>
+        </a:xfrm>
+      </p:grpSpPr>
+      <p:sp>
+        <p:nvSpPr>
+          <p:cNvPr id="214" name="Google Shape;214;p49"/>
+          <p:cNvSpPr txBox="1">
+            <a:spLocks noGrp="1"/>
+          </p:cNvSpPr>
+          <p:nvPr>
+            <p:ph type="title"/>
+          </p:nvPr>
+        </p:nvSpPr>
+        <p:spPr>
+          <a:xfrm>
+            <a:off x="500550" y="330724"/>
+            <a:ext cx="8520600" cy="1095900"/>
+          </a:xfrm>
+          <a:prstGeom prst="rect">
+            <a:avLst/>
+          </a:prstGeom>
+        </p:spPr>
+        <p:txBody>
+          <a:bodyPr spcFirstLastPara="1" wrap="square" lIns="91425" tIns="91425" rIns="91425" bIns="91425" anchor="t" anchorCtr="0">
+            <a:noAutofit/>
+          </a:bodyPr>
+          <a:lstStyle/>
+          <a:p>
+            <a:pPr marL="0" lvl="0" indent="0" algn="l" rtl="0">
+              <a:spcBef>
+                <a:spcPts val="0"/>
+              </a:spcBef>
+              <a:spcAft>
+                <a:spcPts val="0"/>
+              </a:spcAft>
+              <a:buNone/>
+            </a:pPr>
+            <a:r>
+              <a:rPr lang="ru" sz="3200" b="1"/>
+              <a:t>Правила вебинара</a:t>
+            </a:r>
+            <a:endParaRPr sz="3200" b="1"/>
+          </a:p>
+        </p:txBody>
+      </p:sp>
+      <p:pic>
+        <p:nvPicPr>
+          <p:cNvPr id="215" name="Google Shape;215;p49"/>
+          <p:cNvPicPr preferRelativeResize="0"/>
+          <p:nvPr/>
+        </p:nvPicPr>
+        <p:blipFill rotWithShape="1">
+          <a:blip r:embed="rId3">
+            <a:alphaModFix/>
+          </a:blip>
+          <a:srcRect/>
+          <a:stretch/>
+        </p:blipFill>
+        <p:spPr>
+          <a:xfrm>
+            <a:off x="837650" y="3951281"/>
+            <a:ext cx="692621" cy="692620"/>
+          </a:xfrm>
+          <a:prstGeom prst="rect">
+            <a:avLst/>
+          </a:prstGeom>
+          <a:noFill/>
+          <a:ln>
+            <a:noFill/>
+          </a:ln>
+        </p:spPr>
+      </p:pic>
+      <p:pic>
+        <p:nvPicPr>
+          <p:cNvPr id="216" name="Google Shape;216;p49"/>
+          <p:cNvPicPr preferRelativeResize="0"/>
+          <p:nvPr/>
+        </p:nvPicPr>
+        <p:blipFill rotWithShape="1">
+          <a:blip r:embed="rId4">
+            <a:alphaModFix/>
+          </a:blip>
+          <a:srcRect/>
+          <a:stretch/>
+        </p:blipFill>
+        <p:spPr>
+          <a:xfrm>
+            <a:off x="837650" y="1281613"/>
+            <a:ext cx="692621" cy="692620"/>
+          </a:xfrm>
+          <a:prstGeom prst="rect">
+            <a:avLst/>
+          </a:prstGeom>
+          <a:noFill/>
+          <a:ln>
+            <a:noFill/>
+          </a:ln>
+        </p:spPr>
+      </p:pic>
+      <p:pic>
+        <p:nvPicPr>
+          <p:cNvPr id="217" name="Google Shape;217;p49"/>
+          <p:cNvPicPr preferRelativeResize="0"/>
+          <p:nvPr/>
+        </p:nvPicPr>
+        <p:blipFill rotWithShape="1">
+          <a:blip r:embed="rId5">
+            <a:alphaModFix/>
+          </a:blip>
+          <a:srcRect/>
+          <a:stretch/>
+        </p:blipFill>
+        <p:spPr>
+          <a:xfrm>
+            <a:off x="837651" y="3061406"/>
+            <a:ext cx="692621" cy="692599"/>
+          </a:xfrm>
+          <a:prstGeom prst="rect">
+            <a:avLst/>
+          </a:prstGeom>
+          <a:noFill/>
+          <a:ln>
+            <a:noFill/>
+          </a:ln>
+        </p:spPr>
+      </p:pic>
+      <p:sp>
+        <p:nvSpPr>
+          <p:cNvPr id="218" name="Google Shape;218;p49"/>
+          <p:cNvSpPr txBox="1"/>
+          <p:nvPr/>
+        </p:nvSpPr>
+        <p:spPr>
+          <a:xfrm>
+            <a:off x="1654525" y="1252250"/>
+            <a:ext cx="2475300" cy="646500"/>
+          </a:xfrm>
+          <a:prstGeom prst="rect">
+            <a:avLst/>
+          </a:prstGeom>
+          <a:noFill/>
+          <a:ln>
+            <a:noFill/>
+          </a:ln>
+        </p:spPr>
+        <p:txBody>
+          <a:bodyPr spcFirstLastPara="1" wrap="square" lIns="91425" tIns="91425" rIns="91425" bIns="91425" anchor="t" anchorCtr="0">
+            <a:spAutoFit/>
+          </a:bodyPr>
+          <a:lstStyle/>
+          <a:p>
+            <a:pPr marL="0" lvl="0" indent="0" algn="l" rtl="0">
+              <a:spcBef>
+                <a:spcPts val="0"/>
+              </a:spcBef>
+              <a:spcAft>
+                <a:spcPts val="0"/>
+              </a:spcAft>
+              <a:buNone/>
+            </a:pPr>
+            <a:r>
+              <a:rPr lang="ru" sz="1500">
+                <a:latin typeface="Roboto"/>
+                <a:ea typeface="Roboto"/>
+                <a:cs typeface="Roboto"/>
+                <a:sym typeface="Roboto"/>
+              </a:rPr>
+              <a:t>Активно</a:t>
+            </a:r>
+            <a:endParaRPr sz="1500">
+              <a:latin typeface="Roboto"/>
+              <a:ea typeface="Roboto"/>
+              <a:cs typeface="Roboto"/>
+              <a:sym typeface="Roboto"/>
+            </a:endParaRPr>
+          </a:p>
+          <a:p>
+            <a:pPr marL="0" lvl="0" indent="0" algn="l" rtl="0">
+              <a:spcBef>
+                <a:spcPts val="0"/>
+              </a:spcBef>
+              <a:spcAft>
+                <a:spcPts val="0"/>
+              </a:spcAft>
+              <a:buNone/>
+            </a:pPr>
+            <a:r>
+              <a:rPr lang="ru" sz="1500">
+                <a:latin typeface="Roboto"/>
+                <a:ea typeface="Roboto"/>
+                <a:cs typeface="Roboto"/>
+                <a:sym typeface="Roboto"/>
+              </a:rPr>
+              <a:t>участвуем</a:t>
+            </a:r>
+            <a:endParaRPr sz="1500">
+              <a:latin typeface="Roboto"/>
+              <a:ea typeface="Roboto"/>
+              <a:cs typeface="Roboto"/>
+              <a:sym typeface="Roboto"/>
+            </a:endParaRPr>
+          </a:p>
+        </p:txBody>
+      </p:sp>
+      <p:sp>
+        <p:nvSpPr>
+          <p:cNvPr id="219" name="Google Shape;219;p49"/>
+          <p:cNvSpPr txBox="1"/>
+          <p:nvPr/>
+        </p:nvSpPr>
+        <p:spPr>
+          <a:xfrm>
+            <a:off x="1654525" y="3066419"/>
+            <a:ext cx="3231000" cy="646500"/>
+          </a:xfrm>
+          <a:prstGeom prst="rect">
+            <a:avLst/>
+          </a:prstGeom>
+          <a:noFill/>
+          <a:ln>
+            <a:noFill/>
+          </a:ln>
+        </p:spPr>
+        <p:txBody>
+          <a:bodyPr spcFirstLastPara="1" wrap="square" lIns="91425" tIns="91425" rIns="91425" bIns="91425" anchor="t" anchorCtr="0">
+            <a:spAutoFit/>
+          </a:bodyPr>
+          <a:lstStyle/>
+          <a:p>
+            <a:pPr marL="0" lvl="0" indent="0" algn="l" rtl="0">
+              <a:spcBef>
+                <a:spcPts val="0"/>
+              </a:spcBef>
+              <a:spcAft>
+                <a:spcPts val="0"/>
+              </a:spcAft>
+              <a:buNone/>
+            </a:pPr>
+            <a:r>
+              <a:rPr lang="ru" sz="1500" dirty="0">
+                <a:latin typeface="Roboto"/>
+                <a:ea typeface="Roboto"/>
+                <a:cs typeface="Roboto"/>
+                <a:sym typeface="Roboto"/>
+              </a:rPr>
+              <a:t>Задаем вопрос</a:t>
+            </a:r>
+            <a:endParaRPr sz="1500" dirty="0">
+              <a:latin typeface="Roboto"/>
+              <a:ea typeface="Roboto"/>
+              <a:cs typeface="Roboto"/>
+              <a:sym typeface="Roboto"/>
+            </a:endParaRPr>
+          </a:p>
+          <a:p>
+            <a:pPr marL="0" lvl="0" indent="0" algn="l" rtl="0">
+              <a:spcBef>
+                <a:spcPts val="0"/>
+              </a:spcBef>
+              <a:spcAft>
+                <a:spcPts val="0"/>
+              </a:spcAft>
+              <a:buNone/>
+            </a:pPr>
+            <a:r>
+              <a:rPr lang="ru" sz="1500" dirty="0">
+                <a:latin typeface="Roboto"/>
+                <a:ea typeface="Roboto"/>
+                <a:cs typeface="Roboto"/>
+                <a:sym typeface="Roboto"/>
+              </a:rPr>
+              <a:t>в чат</a:t>
+            </a:r>
+            <a:endParaRPr sz="1500" dirty="0">
+              <a:latin typeface="Roboto"/>
+              <a:ea typeface="Roboto"/>
+              <a:cs typeface="Roboto"/>
+              <a:sym typeface="Roboto"/>
+            </a:endParaRPr>
+          </a:p>
+        </p:txBody>
+      </p:sp>
+      <p:sp>
+        <p:nvSpPr>
+          <p:cNvPr id="220" name="Google Shape;220;p49"/>
+          <p:cNvSpPr txBox="1"/>
+          <p:nvPr/>
+        </p:nvSpPr>
+        <p:spPr>
+          <a:xfrm>
+            <a:off x="1654525" y="3975059"/>
+            <a:ext cx="3231000" cy="646500"/>
+          </a:xfrm>
+          <a:prstGeom prst="rect">
+            <a:avLst/>
+          </a:prstGeom>
+          <a:noFill/>
+          <a:ln>
+            <a:noFill/>
+          </a:ln>
+        </p:spPr>
+        <p:txBody>
+          <a:bodyPr spcFirstLastPara="1" wrap="square" lIns="91425" tIns="91425" rIns="91425" bIns="91425" anchor="t" anchorCtr="0">
+            <a:spAutoFit/>
+          </a:bodyPr>
+          <a:lstStyle/>
+          <a:p>
+            <a:pPr marL="0" lvl="0" indent="0" algn="l" rtl="0">
+              <a:spcBef>
+                <a:spcPts val="0"/>
+              </a:spcBef>
+              <a:spcAft>
+                <a:spcPts val="0"/>
+              </a:spcAft>
+              <a:buNone/>
+            </a:pPr>
+            <a:r>
+              <a:rPr lang="ru" sz="1500">
+                <a:latin typeface="Roboto"/>
+                <a:ea typeface="Roboto"/>
+                <a:cs typeface="Roboto"/>
+                <a:sym typeface="Roboto"/>
+              </a:rPr>
+              <a:t>Вопросы вижу в чате,</a:t>
+            </a:r>
+            <a:endParaRPr sz="1500">
+              <a:latin typeface="Roboto"/>
+              <a:ea typeface="Roboto"/>
+              <a:cs typeface="Roboto"/>
+              <a:sym typeface="Roboto"/>
+            </a:endParaRPr>
+          </a:p>
+          <a:p>
+            <a:pPr marL="0" lvl="0" indent="0" algn="l" rtl="0">
+              <a:spcBef>
+                <a:spcPts val="0"/>
+              </a:spcBef>
+              <a:spcAft>
+                <a:spcPts val="0"/>
+              </a:spcAft>
+              <a:buNone/>
+            </a:pPr>
+            <a:r>
+              <a:rPr lang="ru" sz="1500">
+                <a:latin typeface="Roboto"/>
+                <a:ea typeface="Roboto"/>
+                <a:cs typeface="Roboto"/>
+                <a:sym typeface="Roboto"/>
+              </a:rPr>
+              <a:t>могу ответить не сразу</a:t>
+            </a:r>
+            <a:endParaRPr sz="1500">
+              <a:latin typeface="Roboto"/>
+              <a:ea typeface="Roboto"/>
+              <a:cs typeface="Roboto"/>
+              <a:sym typeface="Roboto"/>
+            </a:endParaRPr>
+          </a:p>
+        </p:txBody>
+      </p:sp>
+      <p:sp>
+        <p:nvSpPr>
+          <p:cNvPr id="221" name="Google Shape;221;p49"/>
+          <p:cNvSpPr txBox="1"/>
+          <p:nvPr/>
+        </p:nvSpPr>
+        <p:spPr>
+          <a:xfrm>
+            <a:off x="1654525" y="2049300"/>
+            <a:ext cx="2475300" cy="646300"/>
+          </a:xfrm>
+          <a:prstGeom prst="rect">
+            <a:avLst/>
+          </a:prstGeom>
+          <a:noFill/>
+          <a:ln>
+            <a:noFill/>
+          </a:ln>
+        </p:spPr>
+        <p:txBody>
+          <a:bodyPr spcFirstLastPara="1" wrap="square" lIns="91425" tIns="91425" rIns="91425" bIns="91425" anchor="t" anchorCtr="0">
+            <a:spAutoFit/>
+          </a:bodyPr>
+          <a:lstStyle/>
+          <a:p>
+            <a:pPr marL="0" lvl="0" indent="0" algn="l" rtl="0">
+              <a:spcBef>
+                <a:spcPts val="0"/>
+              </a:spcBef>
+              <a:spcAft>
+                <a:spcPts val="0"/>
+              </a:spcAft>
+              <a:buNone/>
+            </a:pPr>
+            <a:r>
+              <a:rPr lang="ru" sz="1500" dirty="0">
+                <a:latin typeface="Roboto"/>
+                <a:ea typeface="Roboto"/>
+                <a:cs typeface="Roboto"/>
+                <a:sym typeface="Roboto"/>
+              </a:rPr>
+              <a:t>Off-topic обсуждаем</a:t>
+            </a:r>
+            <a:endParaRPr sz="1500" dirty="0">
+              <a:latin typeface="Roboto"/>
+              <a:ea typeface="Roboto"/>
+              <a:cs typeface="Roboto"/>
+              <a:sym typeface="Roboto"/>
+            </a:endParaRPr>
+          </a:p>
+          <a:p>
+            <a:pPr marL="0" lvl="0" indent="0" algn="l" rtl="0">
+              <a:spcBef>
+                <a:spcPts val="0"/>
+              </a:spcBef>
+              <a:spcAft>
+                <a:spcPts val="0"/>
+              </a:spcAft>
+              <a:buNone/>
+            </a:pPr>
+            <a:r>
+              <a:rPr lang="ru" sz="1500" dirty="0">
+                <a:latin typeface="Roboto"/>
+                <a:ea typeface="Roboto"/>
+                <a:cs typeface="Roboto"/>
+                <a:sym typeface="Roboto"/>
+              </a:rPr>
+              <a:t>в учебной группе </a:t>
+            </a:r>
+            <a:endParaRPr sz="1500" dirty="0">
+              <a:latin typeface="Roboto"/>
+              <a:ea typeface="Roboto"/>
+              <a:cs typeface="Roboto"/>
+              <a:sym typeface="Roboto"/>
+            </a:endParaRPr>
+          </a:p>
+        </p:txBody>
+      </p:sp>
+      <p:sp>
+        <p:nvSpPr>
+          <p:cNvPr id="222" name="Google Shape;222;p49"/>
+          <p:cNvSpPr/>
+          <p:nvPr/>
+        </p:nvSpPr>
+        <p:spPr>
+          <a:xfrm>
+            <a:off x="6046275" y="-8050"/>
+            <a:ext cx="3097500" cy="5143500"/>
+          </a:xfrm>
+          <a:prstGeom prst="rect">
+            <a:avLst/>
+          </a:prstGeom>
+          <a:solidFill>
+            <a:srgbClr val="212121"/>
+          </a:solidFill>
+          <a:ln>
+            <a:noFill/>
+          </a:ln>
+        </p:spPr>
+        <p:txBody>
+          <a:bodyPr spcFirstLastPara="1" wrap="square" lIns="91425" tIns="91425" rIns="91425" bIns="91425" anchor="ctr" anchorCtr="0">
+            <a:noAutofit/>
+          </a:bodyPr>
+          <a:lstStyle/>
+          <a:p>
+            <a:pPr marL="0" lvl="0" indent="0" algn="l" rtl="0">
+              <a:spcBef>
+                <a:spcPts val="0"/>
+              </a:spcBef>
+              <a:spcAft>
+                <a:spcPts val="0"/>
+              </a:spcAft>
+              <a:buNone/>
+            </a:pPr>
+            <a:endParaRPr/>
+          </a:p>
+        </p:txBody>
+      </p:sp>
+      <p:sp>
+        <p:nvSpPr>
+          <p:cNvPr id="223" name="Google Shape;223;p49"/>
+          <p:cNvSpPr txBox="1"/>
+          <p:nvPr/>
+        </p:nvSpPr>
+        <p:spPr>
+          <a:xfrm>
+            <a:off x="6344063" y="1052963"/>
+            <a:ext cx="2044200" cy="800400"/>
+          </a:xfrm>
+          <a:prstGeom prst="rect">
+            <a:avLst/>
+          </a:prstGeom>
+          <a:noFill/>
+          <a:ln>
+            <a:noFill/>
+          </a:ln>
+        </p:spPr>
+        <p:txBody>
+          <a:bodyPr spcFirstLastPara="1" wrap="square" lIns="91425" tIns="91425" rIns="91425" bIns="91425" anchor="t" anchorCtr="0">
+            <a:spAutoFit/>
+          </a:bodyPr>
+          <a:lstStyle/>
+          <a:p>
+            <a:pPr marL="0" lvl="0" indent="0" algn="l" rtl="0">
+              <a:spcBef>
+                <a:spcPts val="0"/>
+              </a:spcBef>
+              <a:spcAft>
+                <a:spcPts val="0"/>
+              </a:spcAft>
+              <a:buNone/>
+            </a:pPr>
+            <a:r>
+              <a:rPr lang="ru" sz="2000" b="1">
+                <a:solidFill>
+                  <a:schemeClr val="lt1"/>
+                </a:solidFill>
+                <a:latin typeface="Roboto"/>
+                <a:ea typeface="Roboto"/>
+                <a:cs typeface="Roboto"/>
+                <a:sym typeface="Roboto"/>
+              </a:rPr>
+              <a:t>Условные </a:t>
+            </a:r>
+            <a:endParaRPr sz="2000" b="1">
+              <a:solidFill>
+                <a:schemeClr val="lt1"/>
+              </a:solidFill>
+              <a:latin typeface="Roboto"/>
+              <a:ea typeface="Roboto"/>
+              <a:cs typeface="Roboto"/>
+              <a:sym typeface="Roboto"/>
+            </a:endParaRPr>
+          </a:p>
+          <a:p>
+            <a:pPr marL="0" lvl="0" indent="0" algn="l" rtl="0">
+              <a:spcBef>
+                <a:spcPts val="0"/>
+              </a:spcBef>
+              <a:spcAft>
+                <a:spcPts val="0"/>
+              </a:spcAft>
+              <a:buNone/>
+            </a:pPr>
+            <a:r>
+              <a:rPr lang="ru" sz="2000" b="1">
+                <a:solidFill>
+                  <a:schemeClr val="lt1"/>
+                </a:solidFill>
+                <a:latin typeface="Roboto"/>
+                <a:ea typeface="Roboto"/>
+                <a:cs typeface="Roboto"/>
+                <a:sym typeface="Roboto"/>
+              </a:rPr>
+              <a:t>обозначения</a:t>
+            </a:r>
+            <a:endParaRPr sz="2000" b="1">
+              <a:solidFill>
+                <a:schemeClr val="lt1"/>
+              </a:solidFill>
+              <a:latin typeface="Roboto"/>
+              <a:ea typeface="Roboto"/>
+              <a:cs typeface="Roboto"/>
+              <a:sym typeface="Roboto"/>
+            </a:endParaRPr>
+          </a:p>
+        </p:txBody>
+      </p:sp>
+      <p:pic>
+        <p:nvPicPr>
+          <p:cNvPr id="224" name="Google Shape;224;p49"/>
+          <p:cNvPicPr preferRelativeResize="0"/>
+          <p:nvPr/>
+        </p:nvPicPr>
+        <p:blipFill rotWithShape="1">
+          <a:blip r:embed="rId6">
+            <a:alphaModFix/>
+          </a:blip>
+          <a:srcRect/>
+          <a:stretch/>
+        </p:blipFill>
+        <p:spPr>
+          <a:xfrm>
+            <a:off x="6438593" y="1912032"/>
+            <a:ext cx="330301" cy="330303"/>
+          </a:xfrm>
+          <a:prstGeom prst="rect">
+            <a:avLst/>
+          </a:prstGeom>
+          <a:noFill/>
+          <a:ln>
+            <a:noFill/>
+          </a:ln>
+        </p:spPr>
+      </p:pic>
+      <p:sp>
+        <p:nvSpPr>
+          <p:cNvPr id="225" name="Google Shape;225;p49"/>
+          <p:cNvSpPr txBox="1"/>
+          <p:nvPr/>
+        </p:nvSpPr>
+        <p:spPr>
+          <a:xfrm>
+            <a:off x="6829363" y="1898744"/>
+            <a:ext cx="2044200" cy="354000"/>
+          </a:xfrm>
+          <a:prstGeom prst="rect">
+            <a:avLst/>
+          </a:prstGeom>
+          <a:noFill/>
+          <a:ln>
+            <a:noFill/>
+          </a:ln>
+        </p:spPr>
+        <p:txBody>
+          <a:bodyPr spcFirstLastPara="1" wrap="square" lIns="91425" tIns="91425" rIns="91425" bIns="91425" anchor="t" anchorCtr="0">
+            <a:spAutoFit/>
+          </a:bodyPr>
+          <a:lstStyle/>
+          <a:p>
+            <a:pPr marL="0" lvl="0" indent="0" algn="l" rtl="0">
+              <a:spcBef>
+                <a:spcPts val="0"/>
+              </a:spcBef>
+              <a:spcAft>
+                <a:spcPts val="0"/>
+              </a:spcAft>
+              <a:buNone/>
+            </a:pPr>
+            <a:r>
+              <a:rPr lang="ru" sz="1100">
+                <a:solidFill>
+                  <a:schemeClr val="lt1"/>
+                </a:solidFill>
+                <a:latin typeface="Roboto"/>
+                <a:ea typeface="Roboto"/>
+                <a:cs typeface="Roboto"/>
+                <a:sym typeface="Roboto"/>
+              </a:rPr>
+              <a:t>Индивидуально</a:t>
+            </a:r>
+            <a:endParaRPr sz="1100">
+              <a:solidFill>
+                <a:schemeClr val="lt1"/>
+              </a:solidFill>
+              <a:latin typeface="Roboto"/>
+              <a:ea typeface="Roboto"/>
+              <a:cs typeface="Roboto"/>
+              <a:sym typeface="Roboto"/>
+            </a:endParaRPr>
+          </a:p>
+        </p:txBody>
+      </p:sp>
+      <p:pic>
+        <p:nvPicPr>
+          <p:cNvPr id="226" name="Google Shape;226;p49"/>
+          <p:cNvPicPr preferRelativeResize="0"/>
+          <p:nvPr/>
+        </p:nvPicPr>
+        <p:blipFill rotWithShape="1">
+          <a:blip r:embed="rId7">
+            <a:alphaModFix/>
+          </a:blip>
+          <a:srcRect/>
+          <a:stretch/>
+        </p:blipFill>
+        <p:spPr>
+          <a:xfrm>
+            <a:off x="6438593" y="2392126"/>
+            <a:ext cx="330301" cy="330303"/>
+          </a:xfrm>
+          <a:prstGeom prst="rect">
+            <a:avLst/>
+          </a:prstGeom>
+          <a:noFill/>
+          <a:ln>
+            <a:noFill/>
+          </a:ln>
+        </p:spPr>
+      </p:pic>
+      <p:sp>
+        <p:nvSpPr>
+          <p:cNvPr id="227" name="Google Shape;227;p49"/>
+          <p:cNvSpPr txBox="1"/>
+          <p:nvPr/>
+        </p:nvSpPr>
+        <p:spPr>
+          <a:xfrm>
+            <a:off x="6829363" y="2291099"/>
+            <a:ext cx="2044200" cy="523200"/>
+          </a:xfrm>
+          <a:prstGeom prst="rect">
+            <a:avLst/>
+          </a:prstGeom>
+          <a:noFill/>
+          <a:ln>
+            <a:noFill/>
+          </a:ln>
+        </p:spPr>
+        <p:txBody>
+          <a:bodyPr spcFirstLastPara="1" wrap="square" lIns="91425" tIns="91425" rIns="91425" bIns="91425" anchor="t" anchorCtr="0">
+            <a:spAutoFit/>
+          </a:bodyPr>
+          <a:lstStyle/>
+          <a:p>
+            <a:pPr marL="0" lvl="0" indent="0" algn="l" rtl="0">
+              <a:spcBef>
+                <a:spcPts val="0"/>
+              </a:spcBef>
+              <a:spcAft>
+                <a:spcPts val="0"/>
+              </a:spcAft>
+              <a:buNone/>
+            </a:pPr>
+            <a:r>
+              <a:rPr lang="ru" sz="1100">
+                <a:solidFill>
+                  <a:schemeClr val="lt1"/>
+                </a:solidFill>
+                <a:latin typeface="Roboto"/>
+                <a:ea typeface="Roboto"/>
+                <a:cs typeface="Roboto"/>
+                <a:sym typeface="Roboto"/>
+              </a:rPr>
+              <a:t>Время, необходимое</a:t>
+            </a:r>
+            <a:endParaRPr sz="1100">
+              <a:solidFill>
+                <a:schemeClr val="lt1"/>
+              </a:solidFill>
+              <a:latin typeface="Roboto"/>
+              <a:ea typeface="Roboto"/>
+              <a:cs typeface="Roboto"/>
+              <a:sym typeface="Roboto"/>
+            </a:endParaRPr>
+          </a:p>
+          <a:p>
+            <a:pPr marL="0" lvl="0" indent="0" algn="l" rtl="0">
+              <a:spcBef>
+                <a:spcPts val="0"/>
+              </a:spcBef>
+              <a:spcAft>
+                <a:spcPts val="0"/>
+              </a:spcAft>
+              <a:buNone/>
+            </a:pPr>
+            <a:r>
+              <a:rPr lang="ru" sz="1100">
+                <a:solidFill>
+                  <a:schemeClr val="lt1"/>
+                </a:solidFill>
+                <a:latin typeface="Roboto"/>
+                <a:ea typeface="Roboto"/>
+                <a:cs typeface="Roboto"/>
+                <a:sym typeface="Roboto"/>
+              </a:rPr>
+              <a:t>на активность</a:t>
+            </a:r>
+            <a:endParaRPr sz="1100">
+              <a:solidFill>
+                <a:schemeClr val="lt1"/>
+              </a:solidFill>
+              <a:latin typeface="Roboto"/>
+              <a:ea typeface="Roboto"/>
+              <a:cs typeface="Roboto"/>
+              <a:sym typeface="Roboto"/>
+            </a:endParaRPr>
+          </a:p>
+        </p:txBody>
+      </p:sp>
+      <p:pic>
+        <p:nvPicPr>
+          <p:cNvPr id="228" name="Google Shape;228;p49"/>
+          <p:cNvPicPr preferRelativeResize="0"/>
+          <p:nvPr/>
+        </p:nvPicPr>
+        <p:blipFill rotWithShape="1">
+          <a:blip r:embed="rId8">
+            <a:alphaModFix/>
+          </a:blip>
+          <a:srcRect/>
+          <a:stretch/>
+        </p:blipFill>
+        <p:spPr>
+          <a:xfrm>
+            <a:off x="6438593" y="2872220"/>
+            <a:ext cx="330301" cy="330303"/>
+          </a:xfrm>
+          <a:prstGeom prst="rect">
+            <a:avLst/>
+          </a:prstGeom>
+          <a:noFill/>
+          <a:ln>
+            <a:noFill/>
+          </a:ln>
+        </p:spPr>
+      </p:pic>
+      <p:sp>
+        <p:nvSpPr>
+          <p:cNvPr id="229" name="Google Shape;229;p49"/>
+          <p:cNvSpPr txBox="1"/>
+          <p:nvPr/>
+        </p:nvSpPr>
+        <p:spPr>
+          <a:xfrm>
+            <a:off x="6829363" y="2873300"/>
+            <a:ext cx="2044200" cy="354000"/>
+          </a:xfrm>
+          <a:prstGeom prst="rect">
+            <a:avLst/>
+          </a:prstGeom>
+          <a:noFill/>
+          <a:ln>
+            <a:noFill/>
+          </a:ln>
+        </p:spPr>
+        <p:txBody>
+          <a:bodyPr spcFirstLastPara="1" wrap="square" lIns="91425" tIns="91425" rIns="91425" bIns="91425" anchor="t" anchorCtr="0">
+            <a:spAutoFit/>
+          </a:bodyPr>
+          <a:lstStyle/>
+          <a:p>
+            <a:pPr marL="0" lvl="0" indent="0" algn="l" rtl="0">
+              <a:spcBef>
+                <a:spcPts val="0"/>
+              </a:spcBef>
+              <a:spcAft>
+                <a:spcPts val="0"/>
+              </a:spcAft>
+              <a:buNone/>
+            </a:pPr>
+            <a:r>
+              <a:rPr lang="ru" sz="1100">
+                <a:solidFill>
+                  <a:schemeClr val="lt1"/>
+                </a:solidFill>
+                <a:latin typeface="Roboto"/>
+                <a:ea typeface="Roboto"/>
+                <a:cs typeface="Roboto"/>
+                <a:sym typeface="Roboto"/>
+              </a:rPr>
+              <a:t>Пишем в чат</a:t>
+            </a:r>
+            <a:endParaRPr sz="1100">
+              <a:solidFill>
+                <a:schemeClr val="lt1"/>
+              </a:solidFill>
+              <a:latin typeface="Roboto"/>
+              <a:ea typeface="Roboto"/>
+              <a:cs typeface="Roboto"/>
+              <a:sym typeface="Roboto"/>
+            </a:endParaRPr>
+          </a:p>
+        </p:txBody>
+      </p:sp>
+      <p:pic>
+        <p:nvPicPr>
+          <p:cNvPr id="230" name="Google Shape;230;p49"/>
+          <p:cNvPicPr preferRelativeResize="0"/>
+          <p:nvPr/>
+        </p:nvPicPr>
+        <p:blipFill rotWithShape="1">
+          <a:blip r:embed="rId9">
+            <a:alphaModFix/>
+          </a:blip>
+          <a:srcRect/>
+          <a:stretch/>
+        </p:blipFill>
+        <p:spPr>
+          <a:xfrm>
+            <a:off x="6438593" y="3352314"/>
+            <a:ext cx="330301" cy="330303"/>
+          </a:xfrm>
+          <a:prstGeom prst="rect">
+            <a:avLst/>
+          </a:prstGeom>
+          <a:noFill/>
+          <a:ln>
+            <a:noFill/>
+          </a:ln>
+        </p:spPr>
+      </p:pic>
+      <p:sp>
+        <p:nvSpPr>
+          <p:cNvPr id="231" name="Google Shape;231;p49"/>
+          <p:cNvSpPr txBox="1"/>
+          <p:nvPr/>
+        </p:nvSpPr>
+        <p:spPr>
+          <a:xfrm>
+            <a:off x="6829363" y="3359347"/>
+            <a:ext cx="2044200" cy="354000"/>
+          </a:xfrm>
+          <a:prstGeom prst="rect">
+            <a:avLst/>
+          </a:prstGeom>
+          <a:noFill/>
+          <a:ln>
+            <a:noFill/>
+          </a:ln>
+        </p:spPr>
+        <p:txBody>
+          <a:bodyPr spcFirstLastPara="1" wrap="square" lIns="91425" tIns="91425" rIns="91425" bIns="91425" anchor="t" anchorCtr="0">
+            <a:spAutoFit/>
+          </a:bodyPr>
+          <a:lstStyle/>
+          <a:p>
+            <a:pPr marL="0" lvl="0" indent="0" algn="l" rtl="0">
+              <a:spcBef>
+                <a:spcPts val="0"/>
+              </a:spcBef>
+              <a:spcAft>
+                <a:spcPts val="0"/>
+              </a:spcAft>
+              <a:buNone/>
+            </a:pPr>
+            <a:r>
+              <a:rPr lang="ru" sz="1100">
+                <a:solidFill>
+                  <a:schemeClr val="lt1"/>
+                </a:solidFill>
+                <a:latin typeface="Roboto"/>
+                <a:ea typeface="Roboto"/>
+                <a:cs typeface="Roboto"/>
+                <a:sym typeface="Roboto"/>
+              </a:rPr>
+              <a:t>Говорим голосом</a:t>
+            </a:r>
+            <a:endParaRPr sz="1100">
+              <a:solidFill>
+                <a:schemeClr val="lt1"/>
+              </a:solidFill>
+              <a:latin typeface="Roboto"/>
+              <a:ea typeface="Roboto"/>
+              <a:cs typeface="Roboto"/>
+              <a:sym typeface="Roboto"/>
+            </a:endParaRPr>
+          </a:p>
+        </p:txBody>
+      </p:sp>
+      <p:pic>
+        <p:nvPicPr>
+          <p:cNvPr id="232" name="Google Shape;232;p49"/>
+          <p:cNvPicPr preferRelativeResize="0"/>
+          <p:nvPr/>
+        </p:nvPicPr>
+        <p:blipFill rotWithShape="1">
+          <a:blip r:embed="rId10">
+            <a:alphaModFix/>
+          </a:blip>
+          <a:srcRect/>
+          <a:stretch/>
+        </p:blipFill>
+        <p:spPr>
+          <a:xfrm>
+            <a:off x="6438593" y="3832409"/>
+            <a:ext cx="330301" cy="330301"/>
+          </a:xfrm>
+          <a:prstGeom prst="rect">
+            <a:avLst/>
+          </a:prstGeom>
+          <a:noFill/>
+          <a:ln>
+            <a:noFill/>
+          </a:ln>
+        </p:spPr>
+      </p:pic>
+      <p:sp>
+        <p:nvSpPr>
+          <p:cNvPr id="233" name="Google Shape;233;p49"/>
+          <p:cNvSpPr txBox="1"/>
+          <p:nvPr/>
+        </p:nvSpPr>
+        <p:spPr>
+          <a:xfrm>
+            <a:off x="6829363" y="3827568"/>
+            <a:ext cx="2044200" cy="354000"/>
+          </a:xfrm>
+          <a:prstGeom prst="rect">
+            <a:avLst/>
+          </a:prstGeom>
+          <a:noFill/>
+          <a:ln>
+            <a:noFill/>
+          </a:ln>
+        </p:spPr>
+        <p:txBody>
+          <a:bodyPr spcFirstLastPara="1" wrap="square" lIns="91425" tIns="91425" rIns="91425" bIns="91425" anchor="t" anchorCtr="0">
+            <a:spAutoFit/>
+          </a:bodyPr>
+          <a:lstStyle/>
+          <a:p>
+            <a:pPr marL="0" lvl="0" indent="0" algn="l" rtl="0">
+              <a:spcBef>
+                <a:spcPts val="0"/>
+              </a:spcBef>
+              <a:spcAft>
+                <a:spcPts val="0"/>
+              </a:spcAft>
+              <a:buNone/>
+            </a:pPr>
+            <a:r>
+              <a:rPr lang="ru" sz="1100">
+                <a:solidFill>
+                  <a:schemeClr val="lt1"/>
+                </a:solidFill>
+                <a:latin typeface="Roboto"/>
+                <a:ea typeface="Roboto"/>
+                <a:cs typeface="Roboto"/>
+                <a:sym typeface="Roboto"/>
+              </a:rPr>
+              <a:t>Документ</a:t>
+            </a:r>
+            <a:endParaRPr sz="1100">
+              <a:solidFill>
+                <a:schemeClr val="lt1"/>
+              </a:solidFill>
+              <a:latin typeface="Roboto"/>
+              <a:ea typeface="Roboto"/>
+              <a:cs typeface="Roboto"/>
+              <a:sym typeface="Roboto"/>
+            </a:endParaRPr>
+          </a:p>
+        </p:txBody>
+      </p:sp>
+      <p:pic>
+        <p:nvPicPr>
+          <p:cNvPr id="234" name="Google Shape;234;p49"/>
+          <p:cNvPicPr preferRelativeResize="0"/>
+          <p:nvPr/>
+        </p:nvPicPr>
+        <p:blipFill rotWithShape="1">
+          <a:blip r:embed="rId11">
+            <a:alphaModFix/>
+          </a:blip>
+          <a:srcRect/>
+          <a:stretch/>
+        </p:blipFill>
+        <p:spPr>
+          <a:xfrm>
+            <a:off x="6438593" y="4312503"/>
+            <a:ext cx="330301" cy="330303"/>
+          </a:xfrm>
+          <a:prstGeom prst="rect">
+            <a:avLst/>
+          </a:prstGeom>
+          <a:noFill/>
+          <a:ln>
+            <a:noFill/>
+          </a:ln>
+        </p:spPr>
+      </p:pic>
+      <p:sp>
+        <p:nvSpPr>
+          <p:cNvPr id="235" name="Google Shape;235;p49"/>
+          <p:cNvSpPr txBox="1"/>
+          <p:nvPr/>
+        </p:nvSpPr>
+        <p:spPr>
+          <a:xfrm>
+            <a:off x="6829363" y="4223086"/>
+            <a:ext cx="2044200" cy="523200"/>
+          </a:xfrm>
+          <a:prstGeom prst="rect">
+            <a:avLst/>
+          </a:prstGeom>
+          <a:noFill/>
+          <a:ln>
+            <a:noFill/>
+          </a:ln>
+        </p:spPr>
+        <p:txBody>
+          <a:bodyPr spcFirstLastPara="1" wrap="square" lIns="91425" tIns="91425" rIns="91425" bIns="91425" anchor="t" anchorCtr="0">
+            <a:spAutoFit/>
+          </a:bodyPr>
+          <a:lstStyle/>
+          <a:p>
+            <a:pPr marL="0" lvl="0" indent="0" algn="l" rtl="0">
+              <a:spcBef>
+                <a:spcPts val="0"/>
+              </a:spcBef>
+              <a:spcAft>
+                <a:spcPts val="0"/>
+              </a:spcAft>
+              <a:buNone/>
+            </a:pPr>
+            <a:r>
+              <a:rPr lang="ru" sz="1100">
+                <a:solidFill>
+                  <a:schemeClr val="lt1"/>
+                </a:solidFill>
+                <a:latin typeface="Roboto"/>
+                <a:ea typeface="Roboto"/>
+                <a:cs typeface="Roboto"/>
+                <a:sym typeface="Roboto"/>
+              </a:rPr>
+              <a:t>Ответьте себе или</a:t>
+            </a:r>
+            <a:endParaRPr sz="1100">
+              <a:solidFill>
+                <a:schemeClr val="lt1"/>
+              </a:solidFill>
+              <a:latin typeface="Roboto"/>
+              <a:ea typeface="Roboto"/>
+              <a:cs typeface="Roboto"/>
+              <a:sym typeface="Roboto"/>
+            </a:endParaRPr>
+          </a:p>
+          <a:p>
+            <a:pPr marL="0" lvl="0" indent="0" algn="l" rtl="0">
+              <a:spcBef>
+                <a:spcPts val="0"/>
+              </a:spcBef>
+              <a:spcAft>
+                <a:spcPts val="0"/>
+              </a:spcAft>
+              <a:buNone/>
+            </a:pPr>
+            <a:r>
+              <a:rPr lang="ru" sz="1100">
+                <a:solidFill>
+                  <a:schemeClr val="lt1"/>
+                </a:solidFill>
+                <a:latin typeface="Roboto"/>
+                <a:ea typeface="Roboto"/>
+                <a:cs typeface="Roboto"/>
+                <a:sym typeface="Roboto"/>
+              </a:rPr>
+              <a:t>задайте вопрос</a:t>
+            </a:r>
+            <a:endParaRPr sz="1100">
+              <a:solidFill>
+                <a:schemeClr val="lt1"/>
+              </a:solidFill>
+              <a:latin typeface="Roboto"/>
+              <a:ea typeface="Roboto"/>
+              <a:cs typeface="Roboto"/>
+              <a:sym typeface="Roboto"/>
+            </a:endParaRPr>
+          </a:p>
+        </p:txBody>
+      </p:sp>
+      <p:pic>
+        <p:nvPicPr>
+          <p:cNvPr id="237" name="Google Shape;237;p49"/>
+          <p:cNvPicPr preferRelativeResize="0"/>
+          <p:nvPr/>
+        </p:nvPicPr>
+        <p:blipFill rotWithShape="1">
+          <a:blip r:embed="rId12">
+            <a:alphaModFix/>
+          </a:blip>
+          <a:srcRect/>
+          <a:stretch/>
+        </p:blipFill>
+        <p:spPr>
+          <a:xfrm>
+            <a:off x="837650" y="2171500"/>
+            <a:ext cx="692625" cy="692625"/>
+          </a:xfrm>
+          <a:prstGeom prst="rect">
+            <a:avLst/>
+          </a:prstGeom>
+          <a:noFill/>
+          <a:ln>
+            <a:noFill/>
+          </a:ln>
+        </p:spPr>
+      </p:pic>
+    </p:spTree>
+  </p:cSld>
+  <p:clrMapOvr>
+    <a:masterClrMapping/>
+  </p:clrMapOvr>
+</p:sld>
+</file>
+
+<file path=ppt/slides/slide30.xml><?xml version="1.0" encoding="utf-8"?>
 <p:sld xmlns:a="http://schemas.openxmlformats.org/drawingml/2006/main" xmlns:r="http://schemas.openxmlformats.org/officeDocument/2006/relationships" xmlns:p="http://schemas.openxmlformats.org/presentationml/2006/main">
   <p:cSld>
     <p:spTree>
@@ -41568,7 +40872,7 @@
 </p:sld>
 </file>
 
-<file path=ppt/slides/slide33.xml><?xml version="1.0" encoding="utf-8"?>
+<file path=ppt/slides/slide31.xml><?xml version="1.0" encoding="utf-8"?>
 <p:sld xmlns:a="http://schemas.openxmlformats.org/drawingml/2006/main" xmlns:r="http://schemas.openxmlformats.org/officeDocument/2006/relationships" xmlns:p="http://schemas.openxmlformats.org/presentationml/2006/main">
   <p:cSld>
     <p:spTree>
@@ -41847,7 +41151,7 @@
 </p:sld>
 </file>
 
-<file path=ppt/slides/slide34.xml><?xml version="1.0" encoding="utf-8"?>
+<file path=ppt/slides/slide32.xml><?xml version="1.0" encoding="utf-8"?>
 <p:sld xmlns:a="http://schemas.openxmlformats.org/drawingml/2006/main" xmlns:r="http://schemas.openxmlformats.org/officeDocument/2006/relationships" xmlns:p="http://schemas.openxmlformats.org/presentationml/2006/main">
   <p:cSld>
     <p:spTree>
@@ -42148,7 +41452,7 @@
 </p:sld>
 </file>
 
-<file path=ppt/slides/slide35.xml><?xml version="1.0" encoding="utf-8"?>
+<file path=ppt/slides/slide33.xml><?xml version="1.0" encoding="utf-8"?>
 <p:sld xmlns:a="http://schemas.openxmlformats.org/drawingml/2006/main" xmlns:r="http://schemas.openxmlformats.org/officeDocument/2006/relationships" xmlns:p="http://schemas.openxmlformats.org/presentationml/2006/main">
   <p:cSld>
     <p:spTree>
@@ -42790,7 +42094,7 @@
 </p:sld>
 </file>
 
-<file path=ppt/slides/slide36.xml><?xml version="1.0" encoding="utf-8"?>
+<file path=ppt/slides/slide34.xml><?xml version="1.0" encoding="utf-8"?>
 <p:sld xmlns:a="http://schemas.openxmlformats.org/drawingml/2006/main" xmlns:r="http://schemas.openxmlformats.org/officeDocument/2006/relationships" xmlns:p="http://schemas.openxmlformats.org/presentationml/2006/main">
   <p:cSld>
     <p:spTree>
@@ -42894,7 +42198,7 @@
 </p:sld>
 </file>
 
-<file path=ppt/slides/slide37.xml><?xml version="1.0" encoding="utf-8"?>
+<file path=ppt/slides/slide35.xml><?xml version="1.0" encoding="utf-8"?>
 <p:sld xmlns:a="http://schemas.openxmlformats.org/drawingml/2006/main" xmlns:r="http://schemas.openxmlformats.org/officeDocument/2006/relationships" xmlns:p="http://schemas.openxmlformats.org/presentationml/2006/main">
   <p:cSld>
     <p:spTree>

</xml_diff>